<commit_message>
Presentation: add DDR Developer (V3) section at the end
Co-Authored-By: Claude Opus 5.5 <noreply@anthropic.com>
Claude-Session: https://claude.ai/code/session_017FnutsU6w5KK1m4HU6hRuq
</commit_message>
<xml_diff>
--- a/SmartDDRv3/presentation/SmartDDR-Presentation.pptx
+++ b/SmartDDRv3/presentation/SmartDDR-Presentation.pptx
@@ -22,9 +22,13 @@
     <p:sldId id="270" r:id="rId16"/>
     <p:sldId id="271" r:id="rId17"/>
     <p:sldId id="272" r:id="rId18"/>
+    <p:sldId id="273" r:id="rId19"/>
+    <p:sldId id="274" r:id="rId20"/>
+    <p:sldId id="275" r:id="rId21"/>
+    <p:sldId id="276" r:id="rId22"/>
   </p:sldIdLst>
   <p:notesMasterIdLst>
-    <p:notesMasterId r:id="rId19"/>
+    <p:notesMasterId r:id="rId23"/>
   </p:notesMasterIdLst>
   <p:sldSz cx="12192000" cy="6858000"/>
   <p:notesSz cx="6858000" cy="12192000"/>
@@ -1222,7 +1226,7 @@
           <a:p>
             <a:r>
               <a:rPr lang="en-US" dirty="0"/>
-              <a:t>Close with the ask: agree a pilot project and the people who will use it.</a:t>
+              <a:t>DDR_DeveloperV3 is the latest version of the DDR Developer page: engineers open a CTD and build its DDR line items here, and SmartDDR and the Dashboard report on the result.</a:t>
             </a:r>
             <a:endParaRPr lang="en-US" dirty="0"/>
           </a:p>
@@ -1246,6 +1250,182 @@
             <a:fld id="{F7021451-1387-4CA6-816F-3879F97B5CBC}" type="slidenum">
               <a:rPr lang="en-US"/>
               <a:t>17</a:t>
+            </a:fld>
+            <a:endParaRPr lang="en-US"/>
+          </a:p>
+        </p:txBody>
+      </p:sp>
+    </p:spTree>
+    <p:extLst>
+      <p:ext uri="{BB962C8B-B14F-4D97-AF65-F5344CB8AC3E}">
+        <p14:creationId xmlns:p14="http://schemas.microsoft.com/office/powerpoint/2010/main" val="1024086991"/>
+      </p:ext>
+    </p:extLst>
+  </p:cSld>
+  <p:clrMapOvr>
+    <a:masterClrMapping/>
+  </p:clrMapOvr>
+</p:notes>
+</file>
+
+<file path=ppt/notesSlides/notesSlide18.xml><?xml version="1.0" encoding="utf-8"?>
+<p:notes xmlns:a="http://schemas.openxmlformats.org/drawingml/2006/main" xmlns:r="http://schemas.openxmlformats.org/officeDocument/2006/relationships" xmlns:p="http://schemas.openxmlformats.org/presentationml/2006/main">
+  <p:cSld>
+    <p:spTree>
+      <p:nvGrpSpPr>
+        <p:cNvPr id="1" name=""/>
+        <p:cNvGrpSpPr/>
+        <p:nvPr/>
+      </p:nvGrpSpPr>
+      <p:grpSpPr>
+        <a:xfrm>
+          <a:off x="0" y="0"/>
+          <a:ext cx="0" cy="0"/>
+          <a:chOff x="0" y="0"/>
+          <a:chExt cx="0" cy="0"/>
+        </a:xfrm>
+      </p:grpSpPr>
+      <p:sp>
+        <p:nvSpPr>
+          <p:cNvPr id="2" name="Slide Image Placeholder 1"/>
+          <p:cNvSpPr>
+            <a:spLocks noGrp="1" noRot="1" noChangeAspect="1"/>
+          </p:cNvSpPr>
+          <p:nvPr>
+            <p:ph type="sldImg"/>
+          </p:nvPr>
+        </p:nvSpPr>
+        <p:spPr/>
+      </p:sp>
+      <p:sp>
+        <p:nvSpPr>
+          <p:cNvPr id="3" name="Notes Placeholder 2"/>
+          <p:cNvSpPr>
+            <a:spLocks noGrp="1"/>
+          </p:cNvSpPr>
+          <p:nvPr>
+            <p:ph type="body" idx="1"/>
+          </p:nvPr>
+        </p:nvSpPr>
+        <p:spPr/>
+        <p:txBody>
+          <a:bodyPr/>
+          <a:lstStyle/>
+          <a:p>
+            <a:r>
+              <a:rPr lang="en-US" dirty="0"/>
+              <a:t>Walk the flow. The KPI row (CTD hours, DDR hours, variance, line items, match status) refreshes on every change, so the engineer sees immediately whether the DDR matches the CTD.</a:t>
+            </a:r>
+            <a:endParaRPr lang="en-US" dirty="0"/>
+          </a:p>
+        </p:txBody>
+      </p:sp>
+      <p:sp>
+        <p:nvSpPr>
+          <p:cNvPr id="4" name="Slide Number Placeholder 3"/>
+          <p:cNvSpPr>
+            <a:spLocks noGrp="1"/>
+          </p:cNvSpPr>
+          <p:nvPr>
+            <p:ph type="sldNum" sz="quarter" idx="10"/>
+          </p:nvPr>
+        </p:nvSpPr>
+        <p:spPr/>
+        <p:txBody>
+          <a:bodyPr/>
+          <a:lstStyle/>
+          <a:p>
+            <a:fld id="{F7021451-1387-4CA6-816F-3879F97B5CBC}" type="slidenum">
+              <a:rPr lang="en-US"/>
+              <a:t>18</a:t>
+            </a:fld>
+            <a:endParaRPr lang="en-US"/>
+          </a:p>
+        </p:txBody>
+      </p:sp>
+    </p:spTree>
+    <p:extLst>
+      <p:ext uri="{BB962C8B-B14F-4D97-AF65-F5344CB8AC3E}">
+        <p14:creationId xmlns:p14="http://schemas.microsoft.com/office/powerpoint/2010/main" val="1024086991"/>
+      </p:ext>
+    </p:extLst>
+  </p:cSld>
+  <p:clrMapOvr>
+    <a:masterClrMapping/>
+  </p:clrMapOvr>
+</p:notes>
+</file>
+
+<file path=ppt/notesSlides/notesSlide19.xml><?xml version="1.0" encoding="utf-8"?>
+<p:notes xmlns:a="http://schemas.openxmlformats.org/drawingml/2006/main" xmlns:r="http://schemas.openxmlformats.org/officeDocument/2006/relationships" xmlns:p="http://schemas.openxmlformats.org/presentationml/2006/main">
+  <p:cSld>
+    <p:spTree>
+      <p:nvGrpSpPr>
+        <p:cNvPr id="1" name=""/>
+        <p:cNvGrpSpPr/>
+        <p:nvPr/>
+      </p:nvGrpSpPr>
+      <p:grpSpPr>
+        <a:xfrm>
+          <a:off x="0" y="0"/>
+          <a:ext cx="0" cy="0"/>
+          <a:chOff x="0" y="0"/>
+          <a:chExt cx="0" cy="0"/>
+        </a:xfrm>
+      </p:grpSpPr>
+      <p:sp>
+        <p:nvSpPr>
+          <p:cNvPr id="2" name="Slide Image Placeholder 1"/>
+          <p:cNvSpPr>
+            <a:spLocks noGrp="1" noRot="1" noChangeAspect="1"/>
+          </p:cNvSpPr>
+          <p:nvPr>
+            <p:ph type="sldImg"/>
+          </p:nvPr>
+        </p:nvSpPr>
+        <p:spPr/>
+      </p:sp>
+      <p:sp>
+        <p:nvSpPr>
+          <p:cNvPr id="3" name="Notes Placeholder 2"/>
+          <p:cNvSpPr>
+            <a:spLocks noGrp="1"/>
+          </p:cNvSpPr>
+          <p:nvPr>
+            <p:ph type="body" idx="1"/>
+          </p:nvPr>
+        </p:nvSpPr>
+        <p:spPr/>
+        <p:txBody>
+          <a:bodyPr/>
+          <a:lstStyle/>
+          <a:p>
+            <a:r>
+              <a:rPr lang="en-US" dirty="0"/>
+              <a:t>The multiplier opens from Quick Actions or from any row. Mode A uses the DUM sequence, Mode B increments the trailing digits (0001 to 0002 and so on). The PLIP footer appears whenever a PLIP is picked or typed.</a:t>
+            </a:r>
+            <a:endParaRPr lang="en-US" dirty="0"/>
+          </a:p>
+        </p:txBody>
+      </p:sp>
+      <p:sp>
+        <p:nvSpPr>
+          <p:cNvPr id="4" name="Slide Number Placeholder 3"/>
+          <p:cNvSpPr>
+            <a:spLocks noGrp="1"/>
+          </p:cNvSpPr>
+          <p:nvPr>
+            <p:ph type="sldNum" sz="quarter" idx="10"/>
+          </p:nvPr>
+        </p:nvSpPr>
+        <p:spPr/>
+        <p:txBody>
+          <a:bodyPr/>
+          <a:lstStyle/>
+          <a:p>
+            <a:fld id="{F7021451-1387-4CA6-816F-3879F97B5CBC}" type="slidenum">
+              <a:rPr lang="en-US"/>
+              <a:t>19</a:t>
             </a:fld>
             <a:endParaRPr lang="en-US"/>
           </a:p>
@@ -1334,6 +1514,182 @@
             <a:fld id="{F7021451-1387-4CA6-816F-3879F97B5CBC}" type="slidenum">
               <a:rPr lang="en-US"/>
               <a:t>2</a:t>
+            </a:fld>
+            <a:endParaRPr lang="en-US"/>
+          </a:p>
+        </p:txBody>
+      </p:sp>
+    </p:spTree>
+    <p:extLst>
+      <p:ext uri="{BB962C8B-B14F-4D97-AF65-F5344CB8AC3E}">
+        <p14:creationId xmlns:p14="http://schemas.microsoft.com/office/powerpoint/2010/main" val="1024086991"/>
+      </p:ext>
+    </p:extLst>
+  </p:cSld>
+  <p:clrMapOvr>
+    <a:masterClrMapping/>
+  </p:clrMapOvr>
+</p:notes>
+</file>
+
+<file path=ppt/notesSlides/notesSlide20.xml><?xml version="1.0" encoding="utf-8"?>
+<p:notes xmlns:a="http://schemas.openxmlformats.org/drawingml/2006/main" xmlns:r="http://schemas.openxmlformats.org/officeDocument/2006/relationships" xmlns:p="http://schemas.openxmlformats.org/presentationml/2006/main">
+  <p:cSld>
+    <p:spTree>
+      <p:nvGrpSpPr>
+        <p:cNvPr id="1" name=""/>
+        <p:cNvGrpSpPr/>
+        <p:nvPr/>
+      </p:nvGrpSpPr>
+      <p:grpSpPr>
+        <a:xfrm>
+          <a:off x="0" y="0"/>
+          <a:ext cx="0" cy="0"/>
+          <a:chOff x="0" y="0"/>
+          <a:chExt cx="0" cy="0"/>
+        </a:xfrm>
+      </p:grpSpPr>
+      <p:sp>
+        <p:nvSpPr>
+          <p:cNvPr id="2" name="Slide Image Placeholder 1"/>
+          <p:cNvSpPr>
+            <a:spLocks noGrp="1" noRot="1" noChangeAspect="1"/>
+          </p:cNvSpPr>
+          <p:nvPr>
+            <p:ph type="sldImg"/>
+          </p:nvPr>
+        </p:nvSpPr>
+        <p:spPr/>
+      </p:sp>
+      <p:sp>
+        <p:nvSpPr>
+          <p:cNvPr id="3" name="Notes Placeholder 2"/>
+          <p:cNvSpPr>
+            <a:spLocks noGrp="1"/>
+          </p:cNvSpPr>
+          <p:nvPr>
+            <p:ph type="body" idx="1"/>
+          </p:nvPr>
+        </p:nvSpPr>
+        <p:spPr/>
+        <p:txBody>
+          <a:bodyPr/>
+          <a:lstStyle/>
+          <a:p>
+            <a:r>
+              <a:rPr lang="en-US" dirty="0"/>
+              <a:t>Like the other pages, DDR_DeveloperV3 was reviewed by hand against the original but not compiled or run against the real database. The Prev/Next scoping is the one known open item.</a:t>
+            </a:r>
+            <a:endParaRPr lang="en-US" dirty="0"/>
+          </a:p>
+        </p:txBody>
+      </p:sp>
+      <p:sp>
+        <p:nvSpPr>
+          <p:cNvPr id="4" name="Slide Number Placeholder 3"/>
+          <p:cNvSpPr>
+            <a:spLocks noGrp="1"/>
+          </p:cNvSpPr>
+          <p:nvPr>
+            <p:ph type="sldNum" sz="quarter" idx="10"/>
+          </p:nvPr>
+        </p:nvSpPr>
+        <p:spPr/>
+        <p:txBody>
+          <a:bodyPr/>
+          <a:lstStyle/>
+          <a:p>
+            <a:fld id="{F7021451-1387-4CA6-816F-3879F97B5CBC}" type="slidenum">
+              <a:rPr lang="en-US"/>
+              <a:t>20</a:t>
+            </a:fld>
+            <a:endParaRPr lang="en-US"/>
+          </a:p>
+        </p:txBody>
+      </p:sp>
+    </p:spTree>
+    <p:extLst>
+      <p:ext uri="{BB962C8B-B14F-4D97-AF65-F5344CB8AC3E}">
+        <p14:creationId xmlns:p14="http://schemas.microsoft.com/office/powerpoint/2010/main" val="1024086991"/>
+      </p:ext>
+    </p:extLst>
+  </p:cSld>
+  <p:clrMapOvr>
+    <a:masterClrMapping/>
+  </p:clrMapOvr>
+</p:notes>
+</file>
+
+<file path=ppt/notesSlides/notesSlide21.xml><?xml version="1.0" encoding="utf-8"?>
+<p:notes xmlns:a="http://schemas.openxmlformats.org/drawingml/2006/main" xmlns:r="http://schemas.openxmlformats.org/officeDocument/2006/relationships" xmlns:p="http://schemas.openxmlformats.org/presentationml/2006/main">
+  <p:cSld>
+    <p:spTree>
+      <p:nvGrpSpPr>
+        <p:cNvPr id="1" name=""/>
+        <p:cNvGrpSpPr/>
+        <p:nvPr/>
+      </p:nvGrpSpPr>
+      <p:grpSpPr>
+        <a:xfrm>
+          <a:off x="0" y="0"/>
+          <a:ext cx="0" cy="0"/>
+          <a:chOff x="0" y="0"/>
+          <a:chExt cx="0" cy="0"/>
+        </a:xfrm>
+      </p:grpSpPr>
+      <p:sp>
+        <p:nvSpPr>
+          <p:cNvPr id="2" name="Slide Image Placeholder 1"/>
+          <p:cNvSpPr>
+            <a:spLocks noGrp="1" noRot="1" noChangeAspect="1"/>
+          </p:cNvSpPr>
+          <p:nvPr>
+            <p:ph type="sldImg"/>
+          </p:nvPr>
+        </p:nvSpPr>
+        <p:spPr/>
+      </p:sp>
+      <p:sp>
+        <p:nvSpPr>
+          <p:cNvPr id="3" name="Notes Placeholder 2"/>
+          <p:cNvSpPr>
+            <a:spLocks noGrp="1"/>
+          </p:cNvSpPr>
+          <p:nvPr>
+            <p:ph type="body" idx="1"/>
+          </p:nvPr>
+        </p:nvSpPr>
+        <p:spPr/>
+        <p:txBody>
+          <a:bodyPr/>
+          <a:lstStyle/>
+          <a:p>
+            <a:r>
+              <a:rPr lang="en-US" dirty="0"/>
+              <a:t>Close with the ask: agree a pilot project and the people who will use it.</a:t>
+            </a:r>
+            <a:endParaRPr lang="en-US" dirty="0"/>
+          </a:p>
+        </p:txBody>
+      </p:sp>
+      <p:sp>
+        <p:nvSpPr>
+          <p:cNvPr id="4" name="Slide Number Placeholder 3"/>
+          <p:cNvSpPr>
+            <a:spLocks noGrp="1"/>
+          </p:cNvSpPr>
+          <p:nvPr>
+            <p:ph type="sldNum" sz="quarter" idx="10"/>
+          </p:nvPr>
+        </p:nvSpPr>
+        <p:spPr/>
+        <p:txBody>
+          <a:bodyPr/>
+          <a:lstStyle/>
+          <a:p>
+            <a:fld id="{F7021451-1387-4CA6-816F-3879F97B5CBC}" type="slidenum">
+              <a:rPr lang="en-US"/>
+              <a:t>21</a:t>
             </a:fld>
             <a:endParaRPr lang="en-US"/>
           </a:p>
@@ -3235,7 +3591,7 @@
                 <a:ea typeface="Calibri" pitchFamily="34" charset="-122"/>
                 <a:cs typeface="Calibri" pitchFamily="34" charset="-120"/>
               </a:rPr>
-              <a:t>SmartDDR v3 · DDR Dashboard</a:t>
+              <a:t>SmartDDR v3 · DDR Dashboard · DDR Developer</a:t>
             </a:r>
             <a:endParaRPr lang="en-US" sz="1000" dirty="0"/>
           </a:p>
@@ -3800,7 +4156,7 @@
                 <a:ea typeface="Calibri" pitchFamily="34" charset="-122"/>
                 <a:cs typeface="Calibri" pitchFamily="34" charset="-120"/>
               </a:rPr>
-              <a:t>SmartDDR v3 · DDR Dashboard</a:t>
+              <a:t>SmartDDR v3 · DDR Dashboard · DDR Developer</a:t>
             </a:r>
             <a:endParaRPr lang="en-US" sz="1000" dirty="0"/>
           </a:p>
@@ -4434,7 +4790,7 @@
                 <a:ea typeface="Calibri" pitchFamily="34" charset="-122"/>
                 <a:cs typeface="Calibri" pitchFamily="34" charset="-120"/>
               </a:rPr>
-              <a:t>SmartDDR v3 · DDR Dashboard</a:t>
+              <a:t>SmartDDR v3 · DDR Dashboard · DDR Developer</a:t>
             </a:r>
             <a:endParaRPr lang="en-US" sz="1000" dirty="0"/>
           </a:p>
@@ -5009,7 +5365,7 @@
                 <a:ea typeface="Calibri" pitchFamily="34" charset="-122"/>
                 <a:cs typeface="Calibri" pitchFamily="34" charset="-120"/>
               </a:rPr>
-              <a:t>SmartDDR v3 · DDR Dashboard</a:t>
+              <a:t>SmartDDR v3 · DDR Dashboard · DDR Developer</a:t>
             </a:r>
             <a:endParaRPr lang="en-US" sz="1000" dirty="0"/>
           </a:p>
@@ -6040,7 +6396,7 @@
                 <a:ea typeface="Calibri" pitchFamily="34" charset="-122"/>
                 <a:cs typeface="Calibri" pitchFamily="34" charset="-120"/>
               </a:rPr>
-              <a:t>SmartDDR v3 · DDR Dashboard</a:t>
+              <a:t>SmartDDR v3 · DDR Dashboard · DDR Developer</a:t>
             </a:r>
             <a:endParaRPr lang="en-US" sz="1000" dirty="0"/>
           </a:p>
@@ -6986,7 +7342,7 @@
                 <a:ea typeface="Calibri" pitchFamily="34" charset="-122"/>
                 <a:cs typeface="Calibri" pitchFamily="34" charset="-120"/>
               </a:rPr>
-              <a:t>SmartDDR v3 · DDR Dashboard</a:t>
+              <a:t>SmartDDR v3 · DDR Dashboard · DDR Developer</a:t>
             </a:r>
             <a:endParaRPr lang="en-US" sz="1000" dirty="0"/>
           </a:p>
@@ -8114,7 +8470,7 @@
                 <a:ea typeface="Calibri" pitchFamily="34" charset="-122"/>
                 <a:cs typeface="Calibri" pitchFamily="34" charset="-120"/>
               </a:rPr>
-              <a:t>SmartDDR v3 · DDR Dashboard</a:t>
+              <a:t>SmartDDR v3 · DDR Dashboard · DDR Developer</a:t>
             </a:r>
             <a:endParaRPr lang="en-US" sz="1000" dirty="0"/>
           </a:p>
@@ -8206,8 +8562,8 @@
         </p:nvSpPr>
         <p:spPr>
           <a:xfrm>
-            <a:off x="548640" y="822960"/>
-            <a:ext cx="6400800" cy="822960"/>
+            <a:off x="548640" y="1463040"/>
+            <a:ext cx="2743200" cy="1097280"/>
           </a:xfrm>
           <a:prstGeom prst="rect">
             <a:avLst/>
@@ -8223,79 +8579,30 @@
               <a:buNone/>
             </a:pPr>
             <a:r>
-              <a:rPr lang="en-US" sz="4000" b="1" dirty="0">
-                <a:solidFill>
-                  <a:srgbClr val="FFFFFF"/>
+              <a:rPr lang="en-US" sz="7200" b="1" dirty="0">
+                <a:solidFill>
+                  <a:srgbClr val="14B8A6"/>
                 </a:solidFill>
                 <a:latin typeface="Arial" pitchFamily="34" charset="0"/>
                 <a:ea typeface="Arial" pitchFamily="34" charset="-122"/>
                 <a:cs typeface="Arial" pitchFamily="34" charset="-120"/>
               </a:rPr>
-              <a:t>Next steps</a:t>
-            </a:r>
-            <a:endParaRPr lang="en-US" sz="4000" dirty="0"/>
-          </a:p>
-        </p:txBody>
-      </p:sp>
-      <p:sp>
-        <p:nvSpPr>
-          <p:cNvPr id="3" name="Shape 1"/>
-          <p:cNvSpPr/>
-          <p:nvPr/>
-        </p:nvSpPr>
-        <p:spPr>
-          <a:xfrm>
-            <a:off x="548640" y="1920240"/>
-            <a:ext cx="548640" cy="548640"/>
-          </a:xfrm>
-          <a:prstGeom prst="ellipse">
-            <a:avLst/>
-          </a:prstGeom>
-          <a:solidFill>
-            <a:srgbClr val="14B8A6"/>
-          </a:solidFill>
-          <a:ln w="12700">
-            <a:solidFill>
-              <a:srgbClr val="14B8A6"/>
-            </a:solidFill>
-            <a:prstDash val="solid"/>
-          </a:ln>
-        </p:spPr>
-      </p:sp>
-      <p:pic>
-        <p:nvPicPr>
-          <p:cNvPr id="4" name="Image 0" descr="preencoded.png">    </p:cNvPr>
-          <p:cNvPicPr>
-            <a:picLocks noChangeAspect="1"/>
-          </p:cNvPicPr>
-          <p:nvPr/>
-        </p:nvPicPr>
-        <p:blipFill>
-          <a:blip r:embed="rId2"/>
-          <a:stretch>
-            <a:fillRect/>
-          </a:stretch>
-        </p:blipFill>
-        <p:spPr>
-          <a:xfrm>
-            <a:off x="691286" y="2062886"/>
-            <a:ext cx="263347" cy="263347"/>
-          </a:xfrm>
-          <a:prstGeom prst="rect">
-            <a:avLst/>
-          </a:prstGeom>
-        </p:spPr>
-      </p:pic>
-      <p:sp>
-        <p:nvSpPr>
-          <p:cNvPr id="5" name="Text 2"/>
-          <p:cNvSpPr txBox="1"/>
-          <p:nvPr/>
-        </p:nvSpPr>
-        <p:spPr>
-          <a:xfrm>
-            <a:off x="1280160" y="1920240"/>
-            <a:ext cx="5120640" cy="548640"/>
+              <a:t>03</a:t>
+            </a:r>
+            <a:endParaRPr lang="en-US" sz="7200" dirty="0"/>
+          </a:p>
+        </p:txBody>
+      </p:sp>
+      <p:sp>
+        <p:nvSpPr>
+          <p:cNvPr id="3" name="Text 1"/>
+          <p:cNvSpPr txBox="1"/>
+          <p:nvPr/>
+        </p:nvSpPr>
+        <p:spPr>
+          <a:xfrm>
+            <a:off x="548640" y="2651760"/>
+            <a:ext cx="5669280" cy="914400"/>
           </a:xfrm>
           <a:prstGeom prst="rect">
             <a:avLst/>
@@ -8311,337 +8618,73 @@
               <a:buNone/>
             </a:pPr>
             <a:r>
-              <a:rPr lang="en-US" sz="1900" dirty="0">
+              <a:rPr lang="en-US" sz="4400" b="1" dirty="0">
                 <a:solidFill>
                   <a:srgbClr val="FFFFFF"/>
-                </a:solidFill>
-                <a:latin typeface="Calibri" pitchFamily="34" charset="0"/>
-                <a:ea typeface="Calibri" pitchFamily="34" charset="-122"/>
-                <a:cs typeface="Calibri" pitchFamily="34" charset="-120"/>
-              </a:rPr>
-              <a:t>Agree the pilot project and users</a:t>
-            </a:r>
-            <a:endParaRPr lang="en-US" sz="1900" dirty="0"/>
-          </a:p>
-        </p:txBody>
-      </p:sp>
-      <p:sp>
-        <p:nvSpPr>
-          <p:cNvPr id="6" name="Shape 3"/>
-          <p:cNvSpPr/>
-          <p:nvPr/>
-        </p:nvSpPr>
-        <p:spPr>
-          <a:xfrm>
-            <a:off x="548640" y="2788920"/>
-            <a:ext cx="548640" cy="548640"/>
-          </a:xfrm>
-          <a:prstGeom prst="ellipse">
-            <a:avLst/>
-          </a:prstGeom>
-          <a:solidFill>
-            <a:srgbClr val="14B8A6"/>
-          </a:solidFill>
-          <a:ln w="12700">
-            <a:solidFill>
-              <a:srgbClr val="14B8A6"/>
-            </a:solidFill>
-            <a:prstDash val="solid"/>
-          </a:ln>
-        </p:spPr>
-      </p:sp>
-      <p:pic>
-        <p:nvPicPr>
-          <p:cNvPr id="7" name="Image 1" descr="preencoded.png">    </p:cNvPr>
-          <p:cNvPicPr>
-            <a:picLocks noChangeAspect="1"/>
-          </p:cNvPicPr>
-          <p:nvPr/>
-        </p:nvPicPr>
-        <p:blipFill>
-          <a:blip r:embed="rId3"/>
-          <a:stretch>
-            <a:fillRect/>
-          </a:stretch>
-        </p:blipFill>
-        <p:spPr>
-          <a:xfrm>
-            <a:off x="691286" y="2931566"/>
-            <a:ext cx="263347" cy="263347"/>
-          </a:xfrm>
-          <a:prstGeom prst="rect">
-            <a:avLst/>
-          </a:prstGeom>
-        </p:spPr>
-      </p:pic>
-      <p:sp>
-        <p:nvSpPr>
-          <p:cNvPr id="8" name="Text 4"/>
-          <p:cNvSpPr txBox="1"/>
-          <p:nvPr/>
-        </p:nvSpPr>
-        <p:spPr>
-          <a:xfrm>
-            <a:off x="1280160" y="2788920"/>
-            <a:ext cx="5120640" cy="548640"/>
-          </a:xfrm>
-          <a:prstGeom prst="rect">
-            <a:avLst/>
-          </a:prstGeom>
-          <a:noFill/>
-          <a:ln/>
-        </p:spPr>
-        <p:txBody>
-          <a:bodyPr wrap="square" lIns="0" tIns="0" rIns="0" bIns="0" rtlCol="0" anchor="ctr"/>
-          <a:lstStyle/>
-          <a:p>
-            <a:pPr indent="0" marL="0">
-              <a:buNone/>
-            </a:pPr>
-            <a:r>
-              <a:rPr lang="en-US" sz="1900" dirty="0">
-                <a:solidFill>
-                  <a:srgbClr val="FFFFFF"/>
-                </a:solidFill>
-                <a:latin typeface="Calibri" pitchFamily="34" charset="0"/>
-                <a:ea typeface="Calibri" pitchFamily="34" charset="-122"/>
-                <a:cs typeface="Calibri" pitchFamily="34" charset="-120"/>
-              </a:rPr>
-              <a:t>Run the setup script and enable the nightly job</a:t>
-            </a:r>
-            <a:endParaRPr lang="en-US" sz="1900" dirty="0"/>
-          </a:p>
-        </p:txBody>
-      </p:sp>
-      <p:sp>
-        <p:nvSpPr>
-          <p:cNvPr id="9" name="Shape 5"/>
-          <p:cNvSpPr/>
-          <p:nvPr/>
-        </p:nvSpPr>
-        <p:spPr>
-          <a:xfrm>
-            <a:off x="548640" y="3657600"/>
-            <a:ext cx="548640" cy="548640"/>
-          </a:xfrm>
-          <a:prstGeom prst="ellipse">
-            <a:avLst/>
-          </a:prstGeom>
-          <a:solidFill>
-            <a:srgbClr val="14B8A6"/>
-          </a:solidFill>
-          <a:ln w="12700">
-            <a:solidFill>
-              <a:srgbClr val="14B8A6"/>
-            </a:solidFill>
-            <a:prstDash val="solid"/>
-          </a:ln>
-        </p:spPr>
-      </p:sp>
-      <p:pic>
-        <p:nvPicPr>
-          <p:cNvPr id="10" name="Image 2" descr="preencoded.png">    </p:cNvPr>
-          <p:cNvPicPr>
-            <a:picLocks noChangeAspect="1"/>
-          </p:cNvPicPr>
-          <p:nvPr/>
-        </p:nvPicPr>
-        <p:blipFill>
-          <a:blip r:embed="rId4"/>
-          <a:stretch>
-            <a:fillRect/>
-          </a:stretch>
-        </p:blipFill>
-        <p:spPr>
-          <a:xfrm>
-            <a:off x="691286" y="3800246"/>
-            <a:ext cx="263347" cy="263347"/>
-          </a:xfrm>
-          <a:prstGeom prst="rect">
-            <a:avLst/>
-          </a:prstGeom>
-        </p:spPr>
-      </p:pic>
-      <p:sp>
-        <p:nvSpPr>
-          <p:cNvPr id="11" name="Text 6"/>
-          <p:cNvSpPr txBox="1"/>
-          <p:nvPr/>
-        </p:nvSpPr>
-        <p:spPr>
-          <a:xfrm>
-            <a:off x="1280160" y="3657600"/>
-            <a:ext cx="5120640" cy="548640"/>
-          </a:xfrm>
-          <a:prstGeom prst="rect">
-            <a:avLst/>
-          </a:prstGeom>
-          <a:noFill/>
-          <a:ln/>
-        </p:spPr>
-        <p:txBody>
-          <a:bodyPr wrap="square" lIns="0" tIns="0" rIns="0" bIns="0" rtlCol="0" anchor="ctr"/>
-          <a:lstStyle/>
-          <a:p>
-            <a:pPr indent="0" marL="0">
-              <a:buNone/>
-            </a:pPr>
-            <a:r>
-              <a:rPr lang="en-US" sz="1900" dirty="0">
-                <a:solidFill>
-                  <a:srgbClr val="FFFFFF"/>
-                </a:solidFill>
-                <a:latin typeface="Calibri" pitchFamily="34" charset="0"/>
-                <a:ea typeface="Calibri" pitchFamily="34" charset="-122"/>
-                <a:cs typeface="Calibri" pitchFamily="34" charset="-120"/>
-              </a:rPr>
-              <a:t>Capture the first baseline</a:t>
-            </a:r>
-            <a:endParaRPr lang="en-US" sz="1900" dirty="0"/>
-          </a:p>
-        </p:txBody>
-      </p:sp>
-      <p:sp>
-        <p:nvSpPr>
-          <p:cNvPr id="12" name="Shape 7"/>
-          <p:cNvSpPr/>
-          <p:nvPr/>
-        </p:nvSpPr>
-        <p:spPr>
-          <a:xfrm>
-            <a:off x="548640" y="4526280"/>
-            <a:ext cx="548640" cy="548640"/>
-          </a:xfrm>
-          <a:prstGeom prst="ellipse">
-            <a:avLst/>
-          </a:prstGeom>
-          <a:solidFill>
-            <a:srgbClr val="14B8A6"/>
-          </a:solidFill>
-          <a:ln w="12700">
-            <a:solidFill>
-              <a:srgbClr val="14B8A6"/>
-            </a:solidFill>
-            <a:prstDash val="solid"/>
-          </a:ln>
-        </p:spPr>
-      </p:sp>
-      <p:pic>
-        <p:nvPicPr>
-          <p:cNvPr id="13" name="Image 3" descr="preencoded.png">    </p:cNvPr>
-          <p:cNvPicPr>
-            <a:picLocks noChangeAspect="1"/>
-          </p:cNvPicPr>
-          <p:nvPr/>
-        </p:nvPicPr>
-        <p:blipFill>
-          <a:blip r:embed="rId5"/>
-          <a:stretch>
-            <a:fillRect/>
-          </a:stretch>
-        </p:blipFill>
-        <p:spPr>
-          <a:xfrm>
-            <a:off x="691286" y="4668926"/>
-            <a:ext cx="263347" cy="263347"/>
-          </a:xfrm>
-          <a:prstGeom prst="rect">
-            <a:avLst/>
-          </a:prstGeom>
-        </p:spPr>
-      </p:pic>
-      <p:sp>
-        <p:nvSpPr>
-          <p:cNvPr id="14" name="Text 8"/>
-          <p:cNvSpPr txBox="1"/>
-          <p:nvPr/>
-        </p:nvSpPr>
-        <p:spPr>
-          <a:xfrm>
-            <a:off x="1280160" y="4526280"/>
-            <a:ext cx="5120640" cy="548640"/>
-          </a:xfrm>
-          <a:prstGeom prst="rect">
-            <a:avLst/>
-          </a:prstGeom>
-          <a:noFill/>
-          <a:ln/>
-        </p:spPr>
-        <p:txBody>
-          <a:bodyPr wrap="square" lIns="0" tIns="0" rIns="0" bIns="0" rtlCol="0" anchor="ctr"/>
-          <a:lstStyle/>
-          <a:p>
-            <a:pPr indent="0" marL="0">
-              <a:buNone/>
-            </a:pPr>
-            <a:r>
-              <a:rPr lang="en-US" sz="1900" dirty="0">
-                <a:solidFill>
-                  <a:srgbClr val="FFFFFF"/>
-                </a:solidFill>
-                <a:latin typeface="Calibri" pitchFamily="34" charset="0"/>
-                <a:ea typeface="Calibri" pitchFamily="34" charset="-122"/>
-                <a:cs typeface="Calibri" pitchFamily="34" charset="-120"/>
-              </a:rPr>
-              <a:t>Review after two weeks of trend data</a:t>
-            </a:r>
-            <a:endParaRPr lang="en-US" sz="1900" dirty="0"/>
-          </a:p>
-        </p:txBody>
-      </p:sp>
-      <p:sp>
-        <p:nvSpPr>
-          <p:cNvPr id="15" name="Text 9"/>
-          <p:cNvSpPr txBox="1"/>
-          <p:nvPr/>
-        </p:nvSpPr>
-        <p:spPr>
-          <a:xfrm>
-            <a:off x="548640" y="5577840"/>
-            <a:ext cx="4572000" cy="548640"/>
-          </a:xfrm>
-          <a:prstGeom prst="rect">
-            <a:avLst/>
-          </a:prstGeom>
-          <a:noFill/>
-          <a:ln/>
-        </p:spPr>
-        <p:txBody>
-          <a:bodyPr wrap="square" lIns="0" tIns="0" rIns="0" bIns="0" rtlCol="0" anchor="ctr"/>
-          <a:lstStyle/>
-          <a:p>
-            <a:pPr indent="0" marL="0">
-              <a:buNone/>
-            </a:pPr>
-            <a:r>
-              <a:rPr lang="en-US" sz="2200" b="1" dirty="0">
-                <a:solidFill>
-                  <a:srgbClr val="14B8A6"/>
                 </a:solidFill>
                 <a:latin typeface="Arial" pitchFamily="34" charset="0"/>
                 <a:ea typeface="Arial" pitchFamily="34" charset="-122"/>
                 <a:cs typeface="Arial" pitchFamily="34" charset="-120"/>
               </a:rPr>
-              <a:t>Thank you</a:t>
-            </a:r>
-            <a:endParaRPr lang="en-US" sz="2200" dirty="0"/>
-          </a:p>
-        </p:txBody>
-      </p:sp>
-      <p:sp>
-        <p:nvSpPr>
-          <p:cNvPr id="16" name="Shape 10"/>
+              <a:t>DDR Developer</a:t>
+            </a:r>
+            <a:endParaRPr lang="en-US" sz="4400" dirty="0"/>
+          </a:p>
+        </p:txBody>
+      </p:sp>
+      <p:sp>
+        <p:nvSpPr>
+          <p:cNvPr id="4" name="Text 2"/>
+          <p:cNvSpPr txBox="1"/>
+          <p:nvPr/>
+        </p:nvSpPr>
+        <p:spPr>
+          <a:xfrm>
+            <a:off x="548640" y="3657600"/>
+            <a:ext cx="5394960" cy="1097280"/>
+          </a:xfrm>
+          <a:prstGeom prst="rect">
+            <a:avLst/>
+          </a:prstGeom>
+          <a:noFill/>
+          <a:ln/>
+        </p:spPr>
+        <p:txBody>
+          <a:bodyPr wrap="square" lIns="0" tIns="0" rIns="0" bIns="0" rtlCol="0" anchor="ctr"/>
+          <a:lstStyle/>
+          <a:p>
+            <a:pPr indent="0" marL="0">
+              <a:buNone/>
+            </a:pPr>
+            <a:r>
+              <a:rPr lang="en-US" sz="1800" dirty="0">
+                <a:solidFill>
+                  <a:srgbClr val="D7F2EC"/>
+                </a:solidFill>
+                <a:latin typeface="Calibri" pitchFamily="34" charset="0"/>
+                <a:ea typeface="Calibri" pitchFamily="34" charset="-122"/>
+                <a:cs typeface="Calibri" pitchFamily="34" charset="-120"/>
+              </a:rPr>
+              <a:t>Where the DDR is built: turn each CTD deliverable into document and activity lines, with hours that always add up.</a:t>
+            </a:r>
+            <a:endParaRPr lang="en-US" sz="1800" dirty="0"/>
+          </a:p>
+        </p:txBody>
+      </p:sp>
+      <p:sp>
+        <p:nvSpPr>
+          <p:cNvPr id="5" name="Shape 3"/>
           <p:cNvSpPr/>
           <p:nvPr/>
         </p:nvSpPr>
         <p:spPr>
           <a:xfrm>
-            <a:off x="6693408" y="1389888"/>
-            <a:ext cx="4992624" cy="3175254"/>
+            <a:off x="6327648" y="1664208"/>
+            <a:ext cx="5358384" cy="3078099"/>
           </a:xfrm>
           <a:prstGeom prst="roundRect">
             <a:avLst>
-              <a:gd name="adj" fmla="val 2880"/>
+              <a:gd name="adj" fmla="val 2971"/>
             </a:avLst>
           </a:prstGeom>
           <a:solidFill>
@@ -8664,7 +8707,690 @@
       </p:sp>
       <p:pic>
         <p:nvPicPr>
-          <p:cNvPr id="17" name="Image 4" descr="/tmp/claude-0/-home-user-BlazerTest/4e1a4774-871d-567d-86ff-c2c6a1597caf/scratchpad/deck/img/trend.jpg">    </p:cNvPr>
+          <p:cNvPr id="6" name="Image 0" descr="/tmp/claude-0/-home-user-BlazerTest/4e1a4774-871d-567d-86ff-c2c6a1597caf/scratchpad/deck/img/dev_main.jpg">    </p:cNvPr>
+          <p:cNvPicPr>
+            <a:picLocks noChangeAspect="1"/>
+          </p:cNvPicPr>
+          <p:nvPr/>
+        </p:nvPicPr>
+        <p:blipFill>
+          <a:blip r:embed="rId2"/>
+          <a:stretch>
+            <a:fillRect/>
+          </a:stretch>
+        </p:blipFill>
+        <p:spPr>
+          <a:xfrm>
+            <a:off x="6400800" y="1737360"/>
+            <a:ext cx="5212080" cy="2931795"/>
+          </a:xfrm>
+          <a:prstGeom prst="rect">
+            <a:avLst/>
+          </a:prstGeom>
+        </p:spPr>
+      </p:pic>
+      <p:sp>
+        <p:nvSpPr>
+          <p:cNvPr id="7" name="Text 4"/>
+          <p:cNvSpPr txBox="1"/>
+          <p:nvPr/>
+        </p:nvSpPr>
+        <p:spPr>
+          <a:xfrm>
+            <a:off x="548640" y="6446520"/>
+            <a:ext cx="5486400" cy="274320"/>
+          </a:xfrm>
+          <a:prstGeom prst="rect">
+            <a:avLst/>
+          </a:prstGeom>
+          <a:noFill/>
+          <a:ln/>
+        </p:spPr>
+        <p:txBody>
+          <a:bodyPr wrap="square" lIns="0" tIns="0" rIns="0" bIns="0" rtlCol="0" anchor="ctr"/>
+          <a:lstStyle/>
+          <a:p>
+            <a:pPr indent="0" marL="0">
+              <a:buNone/>
+            </a:pPr>
+            <a:r>
+              <a:rPr lang="en-US" sz="1000" dirty="0">
+                <a:solidFill>
+                  <a:srgbClr val="8FC9BF"/>
+                </a:solidFill>
+                <a:latin typeface="Calibri" pitchFamily="34" charset="0"/>
+                <a:ea typeface="Calibri" pitchFamily="34" charset="-122"/>
+                <a:cs typeface="Calibri" pitchFamily="34" charset="-120"/>
+              </a:rPr>
+              <a:t>SmartDDR v3 · DDR Dashboard · DDR Developer</a:t>
+            </a:r>
+            <a:endParaRPr lang="en-US" sz="1000" dirty="0"/>
+          </a:p>
+        </p:txBody>
+      </p:sp>
+      <p:sp>
+        <p:nvSpPr>
+          <p:cNvPr id="8" name="Text 5"/>
+          <p:cNvSpPr txBox="1"/>
+          <p:nvPr/>
+        </p:nvSpPr>
+        <p:spPr>
+          <a:xfrm>
+            <a:off x="11064240" y="6446520"/>
+            <a:ext cx="576072" cy="274320"/>
+          </a:xfrm>
+          <a:prstGeom prst="rect">
+            <a:avLst/>
+          </a:prstGeom>
+          <a:noFill/>
+          <a:ln/>
+        </p:spPr>
+        <p:txBody>
+          <a:bodyPr wrap="square" lIns="0" tIns="0" rIns="0" bIns="0" rtlCol="0" anchor="ctr"/>
+          <a:lstStyle/>
+          <a:p>
+            <a:pPr algn="r" indent="0" marL="0">
+              <a:buNone/>
+            </a:pPr>
+            <a:r>
+              <a:rPr lang="en-US" sz="1000" dirty="0">
+                <a:solidFill>
+                  <a:srgbClr val="8FC9BF"/>
+                </a:solidFill>
+                <a:latin typeface="Calibri" pitchFamily="34" charset="0"/>
+                <a:ea typeface="Calibri" pitchFamily="34" charset="-122"/>
+                <a:cs typeface="Calibri" pitchFamily="34" charset="-120"/>
+              </a:rPr>
+              <a:t>17</a:t>
+            </a:r>
+            <a:endParaRPr lang="en-US" sz="1000" dirty="0"/>
+          </a:p>
+        </p:txBody>
+      </p:sp>
+    </p:spTree>
+  </p:cSld>
+  <p:clrMapOvr>
+    <a:masterClrMapping/>
+  </p:clrMapOvr>
+</p:sld>
+</file>
+
+<file path=ppt/slides/slide18.xml><?xml version="1.0" encoding="utf-8"?>
+<p:sld xmlns:a="http://schemas.openxmlformats.org/drawingml/2006/main" xmlns:r="http://schemas.openxmlformats.org/officeDocument/2006/relationships" xmlns:p="http://schemas.openxmlformats.org/presentationml/2006/main">
+  <p:cSld name="Slide 18">
+    <p:bg>
+      <p:bgPr>
+        <a:blipFill dpi="0" rotWithShape="1">
+          <a:blip r:embed="rId1">
+            <a:lum/>
+          </a:blip>
+          <a:srcRect/>
+          <a:stretch>
+            <a:fillRect/>
+          </a:stretch>
+        </a:blipFill>
+        <a:effectLst/>
+      </p:bgPr>
+    </p:bg>
+    <p:spTree>
+      <p:nvGrpSpPr>
+        <p:cNvPr id="1" name=""/>
+        <p:cNvGrpSpPr/>
+        <p:nvPr/>
+      </p:nvGrpSpPr>
+      <p:grpSpPr>
+        <a:xfrm>
+          <a:off x="0" y="0"/>
+          <a:ext cx="0" cy="0"/>
+          <a:chOff x="0" y="0"/>
+          <a:chExt cx="0" cy="0"/>
+        </a:xfrm>
+      </p:grpSpPr>
+      <p:sp>
+        <p:nvSpPr>
+          <p:cNvPr id="2" name="Text 0"/>
+          <p:cNvSpPr txBox="1"/>
+          <p:nvPr/>
+        </p:nvSpPr>
+        <p:spPr>
+          <a:xfrm>
+            <a:off x="548640" y="365760"/>
+            <a:ext cx="11064240" cy="685800"/>
+          </a:xfrm>
+          <a:prstGeom prst="rect">
+            <a:avLst/>
+          </a:prstGeom>
+          <a:noFill/>
+          <a:ln/>
+        </p:spPr>
+        <p:txBody>
+          <a:bodyPr wrap="square" lIns="0" tIns="0" rIns="0" bIns="0" rtlCol="0" anchor="ctr"/>
+          <a:lstStyle/>
+          <a:p>
+            <a:pPr indent="0" marL="0">
+              <a:buNone/>
+            </a:pPr>
+            <a:r>
+              <a:rPr lang="en-US" sz="3200" b="1" dirty="0">
+                <a:solidFill>
+                  <a:srgbClr val="132828"/>
+                </a:solidFill>
+                <a:latin typeface="Arial" pitchFamily="34" charset="0"/>
+                <a:ea typeface="Arial" pitchFamily="34" charset="-122"/>
+                <a:cs typeface="Arial" pitchFamily="34" charset="-120"/>
+              </a:rPr>
+              <a:t>From CTD to DDR in five steps</a:t>
+            </a:r>
+            <a:endParaRPr lang="en-US" sz="3200" dirty="0"/>
+          </a:p>
+        </p:txBody>
+      </p:sp>
+      <p:sp>
+        <p:nvSpPr>
+          <p:cNvPr id="3" name="Text 1"/>
+          <p:cNvSpPr txBox="1"/>
+          <p:nvPr/>
+        </p:nvSpPr>
+        <p:spPr>
+          <a:xfrm>
+            <a:off x="548640" y="1051560"/>
+            <a:ext cx="11064240" cy="411480"/>
+          </a:xfrm>
+          <a:prstGeom prst="rect">
+            <a:avLst/>
+          </a:prstGeom>
+          <a:noFill/>
+          <a:ln/>
+        </p:spPr>
+        <p:txBody>
+          <a:bodyPr wrap="square" lIns="0" tIns="0" rIns="0" bIns="0" rtlCol="0" anchor="ctr"/>
+          <a:lstStyle/>
+          <a:p>
+            <a:pPr indent="0" marL="0">
+              <a:buNone/>
+            </a:pPr>
+            <a:r>
+              <a:rPr lang="en-US" sz="1600" dirty="0">
+                <a:solidFill>
+                  <a:srgbClr val="5B6B6B"/>
+                </a:solidFill>
+                <a:latin typeface="Calibri" pitchFamily="34" charset="0"/>
+                <a:ea typeface="Calibri" pitchFamily="34" charset="-122"/>
+                <a:cs typeface="Calibri" pitchFamily="34" charset="-120"/>
+              </a:rPr>
+              <a:t>Everything for one CTD on one screen, with a live scorecard that shows when hours match</a:t>
+            </a:r>
+            <a:endParaRPr lang="en-US" sz="1600" dirty="0"/>
+          </a:p>
+        </p:txBody>
+      </p:sp>
+      <p:sp>
+        <p:nvSpPr>
+          <p:cNvPr id="4" name="Shape 2"/>
+          <p:cNvSpPr/>
+          <p:nvPr/>
+        </p:nvSpPr>
+        <p:spPr>
+          <a:xfrm>
+            <a:off x="475488" y="1709928"/>
+            <a:ext cx="6821424" cy="3901059"/>
+          </a:xfrm>
+          <a:prstGeom prst="roundRect">
+            <a:avLst>
+              <a:gd name="adj" fmla="val 2344"/>
+            </a:avLst>
+          </a:prstGeom>
+          <a:solidFill>
+            <a:srgbClr val="FFFFFF"/>
+          </a:solidFill>
+          <a:ln w="9525">
+            <a:solidFill>
+              <a:srgbClr val="D5E6E2"/>
+            </a:solidFill>
+            <a:prstDash val="solid"/>
+          </a:ln>
+          <a:effectLst>
+            <a:outerShdw sx="100000" sy="100000" kx="0" ky="0" algn="bl" rotWithShape="0" blurRad="177800" dist="50800" dir="5400000">
+              <a:srgbClr val="0B2B28">
+                <a:alpha val="22000"/>
+              </a:srgbClr>
+            </a:outerShdw>
+          </a:effectLst>
+        </p:spPr>
+      </p:sp>
+      <p:pic>
+        <p:nvPicPr>
+          <p:cNvPr id="5" name="Image 0" descr="/tmp/claude-0/-home-user-BlazerTest/4e1a4774-871d-567d-86ff-c2c6a1597caf/scratchpad/deck/img/dev_main.jpg">    </p:cNvPr>
+          <p:cNvPicPr>
+            <a:picLocks noChangeAspect="1"/>
+          </p:cNvPicPr>
+          <p:nvPr/>
+        </p:nvPicPr>
+        <p:blipFill>
+          <a:blip r:embed="rId2"/>
+          <a:stretch>
+            <a:fillRect/>
+          </a:stretch>
+        </p:blipFill>
+        <p:spPr>
+          <a:xfrm>
+            <a:off x="548640" y="1783080"/>
+            <a:ext cx="6675120" cy="3754755"/>
+          </a:xfrm>
+          <a:prstGeom prst="rect">
+            <a:avLst/>
+          </a:prstGeom>
+        </p:spPr>
+      </p:pic>
+      <p:sp>
+        <p:nvSpPr>
+          <p:cNvPr id="6" name="Shape 3"/>
+          <p:cNvSpPr/>
+          <p:nvPr/>
+        </p:nvSpPr>
+        <p:spPr>
+          <a:xfrm>
+            <a:off x="7635240" y="1783080"/>
+            <a:ext cx="493776" cy="493776"/>
+          </a:xfrm>
+          <a:prstGeom prst="ellipse">
+            <a:avLst/>
+          </a:prstGeom>
+          <a:solidFill>
+            <a:srgbClr val="0F766E"/>
+          </a:solidFill>
+          <a:ln w="12700">
+            <a:solidFill>
+              <a:srgbClr val="0F766E"/>
+            </a:solidFill>
+            <a:prstDash val="solid"/>
+          </a:ln>
+        </p:spPr>
+      </p:sp>
+      <p:pic>
+        <p:nvPicPr>
+          <p:cNvPr id="7" name="Image 1" descr="preencoded.png">    </p:cNvPr>
+          <p:cNvPicPr>
+            <a:picLocks noChangeAspect="1"/>
+          </p:cNvPicPr>
+          <p:nvPr/>
+        </p:nvPicPr>
+        <p:blipFill>
+          <a:blip r:embed="rId3"/>
+          <a:stretch>
+            <a:fillRect/>
+          </a:stretch>
+        </p:blipFill>
+        <p:spPr>
+          <a:xfrm>
+            <a:off x="7763622" y="1911462"/>
+            <a:ext cx="237012" cy="237012"/>
+          </a:xfrm>
+          <a:prstGeom prst="rect">
+            <a:avLst/>
+          </a:prstGeom>
+        </p:spPr>
+      </p:pic>
+      <p:sp>
+        <p:nvSpPr>
+          <p:cNvPr id="8" name="Text 4"/>
+          <p:cNvSpPr txBox="1"/>
+          <p:nvPr/>
+        </p:nvSpPr>
+        <p:spPr>
+          <a:xfrm>
+            <a:off x="8275320" y="1755648"/>
+            <a:ext cx="3383280" cy="292608"/>
+          </a:xfrm>
+          <a:prstGeom prst="rect">
+            <a:avLst/>
+          </a:prstGeom>
+          <a:noFill/>
+          <a:ln/>
+        </p:spPr>
+        <p:txBody>
+          <a:bodyPr wrap="square" lIns="0" tIns="0" rIns="0" bIns="0" rtlCol="0" anchor="t"/>
+          <a:lstStyle/>
+          <a:p>
+            <a:pPr indent="0" marL="0">
+              <a:buNone/>
+            </a:pPr>
+            <a:r>
+              <a:rPr lang="en-US" sz="1500" b="1" dirty="0">
+                <a:solidFill>
+                  <a:srgbClr val="132828"/>
+                </a:solidFill>
+                <a:latin typeface="Arial" pitchFamily="34" charset="0"/>
+                <a:ea typeface="Arial" pitchFamily="34" charset="-122"/>
+                <a:cs typeface="Arial" pitchFamily="34" charset="-120"/>
+              </a:rPr>
+              <a:t>1. Open the CTD</a:t>
+            </a:r>
+            <a:endParaRPr lang="en-US" sz="1500" dirty="0"/>
+          </a:p>
+        </p:txBody>
+      </p:sp>
+      <p:sp>
+        <p:nvSpPr>
+          <p:cNvPr id="9" name="Text 5"/>
+          <p:cNvSpPr txBox="1"/>
+          <p:nvPr/>
+        </p:nvSpPr>
+        <p:spPr>
+          <a:xfrm>
+            <a:off x="8275320" y="2039112"/>
+            <a:ext cx="3383280" cy="411480"/>
+          </a:xfrm>
+          <a:prstGeom prst="rect">
+            <a:avLst/>
+          </a:prstGeom>
+          <a:noFill/>
+          <a:ln/>
+        </p:spPr>
+        <p:txBody>
+          <a:bodyPr wrap="square" lIns="0" tIns="0" rIns="0" bIns="0" rtlCol="0" anchor="t"/>
+          <a:lstStyle/>
+          <a:p>
+            <a:pPr indent="0" marL="0">
+              <a:buNone/>
+            </a:pPr>
+            <a:r>
+              <a:rPr lang="en-US" sz="1250" dirty="0">
+                <a:solidFill>
+                  <a:srgbClr val="5B6B6B"/>
+                </a:solidFill>
+                <a:latin typeface="Calibri" pitchFamily="34" charset="0"/>
+                <a:ea typeface="Calibri" pitchFamily="34" charset="-122"/>
+                <a:cs typeface="Calibri" pitchFamily="34" charset="-120"/>
+              </a:rPr>
+              <a:t>Search, or step through with Previous / Next.</a:t>
+            </a:r>
+            <a:endParaRPr lang="en-US" sz="1250" dirty="0"/>
+          </a:p>
+        </p:txBody>
+      </p:sp>
+      <p:sp>
+        <p:nvSpPr>
+          <p:cNvPr id="10" name="Shape 6"/>
+          <p:cNvSpPr/>
+          <p:nvPr/>
+        </p:nvSpPr>
+        <p:spPr>
+          <a:xfrm>
+            <a:off x="7635240" y="2542032"/>
+            <a:ext cx="493776" cy="493776"/>
+          </a:xfrm>
+          <a:prstGeom prst="ellipse">
+            <a:avLst/>
+          </a:prstGeom>
+          <a:solidFill>
+            <a:srgbClr val="0F766E"/>
+          </a:solidFill>
+          <a:ln w="12700">
+            <a:solidFill>
+              <a:srgbClr val="0F766E"/>
+            </a:solidFill>
+            <a:prstDash val="solid"/>
+          </a:ln>
+        </p:spPr>
+      </p:sp>
+      <p:pic>
+        <p:nvPicPr>
+          <p:cNvPr id="11" name="Image 2" descr="preencoded.png">    </p:cNvPr>
+          <p:cNvPicPr>
+            <a:picLocks noChangeAspect="1"/>
+          </p:cNvPicPr>
+          <p:nvPr/>
+        </p:nvPicPr>
+        <p:blipFill>
+          <a:blip r:embed="rId4"/>
+          <a:stretch>
+            <a:fillRect/>
+          </a:stretch>
+        </p:blipFill>
+        <p:spPr>
+          <a:xfrm>
+            <a:off x="7763622" y="2670414"/>
+            <a:ext cx="237012" cy="237012"/>
+          </a:xfrm>
+          <a:prstGeom prst="rect">
+            <a:avLst/>
+          </a:prstGeom>
+        </p:spPr>
+      </p:pic>
+      <p:sp>
+        <p:nvSpPr>
+          <p:cNvPr id="12" name="Text 7"/>
+          <p:cNvSpPr txBox="1"/>
+          <p:nvPr/>
+        </p:nvSpPr>
+        <p:spPr>
+          <a:xfrm>
+            <a:off x="8275320" y="2514600"/>
+            <a:ext cx="3383280" cy="292608"/>
+          </a:xfrm>
+          <a:prstGeom prst="rect">
+            <a:avLst/>
+          </a:prstGeom>
+          <a:noFill/>
+          <a:ln/>
+        </p:spPr>
+        <p:txBody>
+          <a:bodyPr wrap="square" lIns="0" tIns="0" rIns="0" bIns="0" rtlCol="0" anchor="t"/>
+          <a:lstStyle/>
+          <a:p>
+            <a:pPr indent="0" marL="0">
+              <a:buNone/>
+            </a:pPr>
+            <a:r>
+              <a:rPr lang="en-US" sz="1500" b="1" dirty="0">
+                <a:solidFill>
+                  <a:srgbClr val="132828"/>
+                </a:solidFill>
+                <a:latin typeface="Arial" pitchFamily="34" charset="0"/>
+                <a:ea typeface="Arial" pitchFamily="34" charset="-122"/>
+                <a:cs typeface="Arial" pitchFamily="34" charset="-120"/>
+              </a:rPr>
+              <a:t>2. Add the lines</a:t>
+            </a:r>
+            <a:endParaRPr lang="en-US" sz="1500" dirty="0"/>
+          </a:p>
+        </p:txBody>
+      </p:sp>
+      <p:sp>
+        <p:nvSpPr>
+          <p:cNvPr id="13" name="Text 8"/>
+          <p:cNvSpPr txBox="1"/>
+          <p:nvPr/>
+        </p:nvSpPr>
+        <p:spPr>
+          <a:xfrm>
+            <a:off x="8275320" y="2798064"/>
+            <a:ext cx="3383280" cy="411480"/>
+          </a:xfrm>
+          <a:prstGeom prst="rect">
+            <a:avLst/>
+          </a:prstGeom>
+          <a:noFill/>
+          <a:ln/>
+        </p:spPr>
+        <p:txBody>
+          <a:bodyPr wrap="square" lIns="0" tIns="0" rIns="0" bIns="0" rtlCol="0" anchor="t"/>
+          <a:lstStyle/>
+          <a:p>
+            <a:pPr indent="0" marL="0">
+              <a:buNone/>
+            </a:pPr>
+            <a:r>
+              <a:rPr lang="en-US" sz="1250" dirty="0">
+                <a:solidFill>
+                  <a:srgbClr val="5B6B6B"/>
+                </a:solidFill>
+                <a:latin typeface="Calibri" pitchFamily="34" charset="0"/>
+                <a:ea typeface="Calibri" pitchFamily="34" charset="-122"/>
+                <a:cs typeface="Calibri" pitchFamily="34" charset="-120"/>
+              </a:rPr>
+              <a:t>Add DDR Line, DDR + Activity, or upload a CSV.</a:t>
+            </a:r>
+            <a:endParaRPr lang="en-US" sz="1250" dirty="0"/>
+          </a:p>
+        </p:txBody>
+      </p:sp>
+      <p:sp>
+        <p:nvSpPr>
+          <p:cNvPr id="14" name="Shape 9"/>
+          <p:cNvSpPr/>
+          <p:nvPr/>
+        </p:nvSpPr>
+        <p:spPr>
+          <a:xfrm>
+            <a:off x="7635240" y="3300984"/>
+            <a:ext cx="493776" cy="493776"/>
+          </a:xfrm>
+          <a:prstGeom prst="ellipse">
+            <a:avLst/>
+          </a:prstGeom>
+          <a:solidFill>
+            <a:srgbClr val="0F766E"/>
+          </a:solidFill>
+          <a:ln w="12700">
+            <a:solidFill>
+              <a:srgbClr val="0F766E"/>
+            </a:solidFill>
+            <a:prstDash val="solid"/>
+          </a:ln>
+        </p:spPr>
+      </p:sp>
+      <p:pic>
+        <p:nvPicPr>
+          <p:cNvPr id="15" name="Image 3" descr="preencoded.png">    </p:cNvPr>
+          <p:cNvPicPr>
+            <a:picLocks noChangeAspect="1"/>
+          </p:cNvPicPr>
+          <p:nvPr/>
+        </p:nvPicPr>
+        <p:blipFill>
+          <a:blip r:embed="rId5"/>
+          <a:stretch>
+            <a:fillRect/>
+          </a:stretch>
+        </p:blipFill>
+        <p:spPr>
+          <a:xfrm>
+            <a:off x="7763622" y="3429366"/>
+            <a:ext cx="237012" cy="237012"/>
+          </a:xfrm>
+          <a:prstGeom prst="rect">
+            <a:avLst/>
+          </a:prstGeom>
+        </p:spPr>
+      </p:pic>
+      <p:sp>
+        <p:nvSpPr>
+          <p:cNvPr id="16" name="Text 10"/>
+          <p:cNvSpPr txBox="1"/>
+          <p:nvPr/>
+        </p:nvSpPr>
+        <p:spPr>
+          <a:xfrm>
+            <a:off x="8275320" y="3273552"/>
+            <a:ext cx="3383280" cy="292608"/>
+          </a:xfrm>
+          <a:prstGeom prst="rect">
+            <a:avLst/>
+          </a:prstGeom>
+          <a:noFill/>
+          <a:ln/>
+        </p:spPr>
+        <p:txBody>
+          <a:bodyPr wrap="square" lIns="0" tIns="0" rIns="0" bIns="0" rtlCol="0" anchor="t"/>
+          <a:lstStyle/>
+          <a:p>
+            <a:pPr indent="0" marL="0">
+              <a:buNone/>
+            </a:pPr>
+            <a:r>
+              <a:rPr lang="en-US" sz="1500" b="1" dirty="0">
+                <a:solidFill>
+                  <a:srgbClr val="132828"/>
+                </a:solidFill>
+                <a:latin typeface="Arial" pitchFamily="34" charset="0"/>
+                <a:ea typeface="Arial" pitchFamily="34" charset="-122"/>
+                <a:cs typeface="Arial" pitchFamily="34" charset="-120"/>
+              </a:rPr>
+              <a:t>3. Pick the PLIP</a:t>
+            </a:r>
+            <a:endParaRPr lang="en-US" sz="1500" dirty="0"/>
+          </a:p>
+        </p:txBody>
+      </p:sp>
+      <p:sp>
+        <p:nvSpPr>
+          <p:cNvPr id="17" name="Text 11"/>
+          <p:cNvSpPr txBox="1"/>
+          <p:nvPr/>
+        </p:nvSpPr>
+        <p:spPr>
+          <a:xfrm>
+            <a:off x="8275320" y="3557016"/>
+            <a:ext cx="3383280" cy="411480"/>
+          </a:xfrm>
+          <a:prstGeom prst="rect">
+            <a:avLst/>
+          </a:prstGeom>
+          <a:noFill/>
+          <a:ln/>
+        </p:spPr>
+        <p:txBody>
+          <a:bodyPr wrap="square" lIns="0" tIns="0" rIns="0" bIns="0" rtlCol="0" anchor="t"/>
+          <a:lstStyle/>
+          <a:p>
+            <a:pPr indent="0" marL="0">
+              <a:buNone/>
+            </a:pPr>
+            <a:r>
+              <a:rPr lang="en-US" sz="1250" dirty="0">
+                <a:solidFill>
+                  <a:srgbClr val="5B6B6B"/>
+                </a:solidFill>
+                <a:latin typeface="Calibri" pitchFamily="34" charset="0"/>
+                <a:ea typeface="Calibri" pitchFamily="34" charset="-122"/>
+                <a:cs typeface="Calibri" pitchFamily="34" charset="-120"/>
+              </a:rPr>
+              <a:t>Critical, HO status and AFC/APP fill in.</a:t>
+            </a:r>
+            <a:endParaRPr lang="en-US" sz="1250" dirty="0"/>
+          </a:p>
+        </p:txBody>
+      </p:sp>
+      <p:sp>
+        <p:nvSpPr>
+          <p:cNvPr id="18" name="Shape 12"/>
+          <p:cNvSpPr/>
+          <p:nvPr/>
+        </p:nvSpPr>
+        <p:spPr>
+          <a:xfrm>
+            <a:off x="7635240" y="4059936"/>
+            <a:ext cx="493776" cy="493776"/>
+          </a:xfrm>
+          <a:prstGeom prst="ellipse">
+            <a:avLst/>
+          </a:prstGeom>
+          <a:solidFill>
+            <a:srgbClr val="0F766E"/>
+          </a:solidFill>
+          <a:ln w="12700">
+            <a:solidFill>
+              <a:srgbClr val="0F766E"/>
+            </a:solidFill>
+            <a:prstDash val="solid"/>
+          </a:ln>
+        </p:spPr>
+      </p:sp>
+      <p:pic>
+        <p:nvPicPr>
+          <p:cNvPr id="19" name="Image 4" descr="preencoded.png">    </p:cNvPr>
           <p:cNvPicPr>
             <a:picLocks noChangeAspect="1"/>
           </p:cNvPicPr>
@@ -8678,14 +9404,1185 @@
         </p:blipFill>
         <p:spPr>
           <a:xfrm>
-            <a:off x="6766560" y="1463040"/>
-            <a:ext cx="4846320" cy="3028950"/>
+            <a:off x="7763622" y="4188318"/>
+            <a:ext cx="237012" cy="237012"/>
           </a:xfrm>
           <a:prstGeom prst="rect">
             <a:avLst/>
           </a:prstGeom>
         </p:spPr>
       </p:pic>
+      <p:sp>
+        <p:nvSpPr>
+          <p:cNvPr id="20" name="Text 13"/>
+          <p:cNvSpPr txBox="1"/>
+          <p:nvPr/>
+        </p:nvSpPr>
+        <p:spPr>
+          <a:xfrm>
+            <a:off x="8275320" y="4032504"/>
+            <a:ext cx="3383280" cy="292608"/>
+          </a:xfrm>
+          <a:prstGeom prst="rect">
+            <a:avLst/>
+          </a:prstGeom>
+          <a:noFill/>
+          <a:ln/>
+        </p:spPr>
+        <p:txBody>
+          <a:bodyPr wrap="square" lIns="0" tIns="0" rIns="0" bIns="0" rtlCol="0" anchor="t"/>
+          <a:lstStyle/>
+          <a:p>
+            <a:pPr indent="0" marL="0">
+              <a:buNone/>
+            </a:pPr>
+            <a:r>
+              <a:rPr lang="en-US" sz="1500" b="1" dirty="0">
+                <a:solidFill>
+                  <a:srgbClr val="132828"/>
+                </a:solidFill>
+                <a:latin typeface="Arial" pitchFamily="34" charset="0"/>
+                <a:ea typeface="Arial" pitchFamily="34" charset="-122"/>
+                <a:cs typeface="Arial" pitchFamily="34" charset="-120"/>
+              </a:rPr>
+              <a:t>4. Balance the hours</a:t>
+            </a:r>
+            <a:endParaRPr lang="en-US" sz="1500" dirty="0"/>
+          </a:p>
+        </p:txBody>
+      </p:sp>
+      <p:sp>
+        <p:nvSpPr>
+          <p:cNvPr id="21" name="Text 14"/>
+          <p:cNvSpPr txBox="1"/>
+          <p:nvPr/>
+        </p:nvSpPr>
+        <p:spPr>
+          <a:xfrm>
+            <a:off x="8275320" y="4315968"/>
+            <a:ext cx="3383280" cy="411480"/>
+          </a:xfrm>
+          <a:prstGeom prst="rect">
+            <a:avLst/>
+          </a:prstGeom>
+          <a:noFill/>
+          <a:ln/>
+        </p:spPr>
+        <p:txBody>
+          <a:bodyPr wrap="square" lIns="0" tIns="0" rIns="0" bIns="0" rtlCol="0" anchor="t"/>
+          <a:lstStyle/>
+          <a:p>
+            <a:pPr indent="0" marL="0">
+              <a:buNone/>
+            </a:pPr>
+            <a:r>
+              <a:rPr lang="en-US" sz="1250" dirty="0">
+                <a:solidFill>
+                  <a:srgbClr val="5B6B6B"/>
+                </a:solidFill>
+                <a:latin typeface="Calibri" pitchFamily="34" charset="0"/>
+                <a:ea typeface="Calibri" pitchFamily="34" charset="-122"/>
+                <a:cs typeface="Calibri" pitchFamily="34" charset="-120"/>
+              </a:rPr>
+              <a:t>Allocate Hours splits the CTD total exactly.</a:t>
+            </a:r>
+            <a:endParaRPr lang="en-US" sz="1250" dirty="0"/>
+          </a:p>
+        </p:txBody>
+      </p:sp>
+      <p:sp>
+        <p:nvSpPr>
+          <p:cNvPr id="22" name="Shape 15"/>
+          <p:cNvSpPr/>
+          <p:nvPr/>
+        </p:nvSpPr>
+        <p:spPr>
+          <a:xfrm>
+            <a:off x="7635240" y="4818888"/>
+            <a:ext cx="493776" cy="493776"/>
+          </a:xfrm>
+          <a:prstGeom prst="ellipse">
+            <a:avLst/>
+          </a:prstGeom>
+          <a:solidFill>
+            <a:srgbClr val="0F766E"/>
+          </a:solidFill>
+          <a:ln w="12700">
+            <a:solidFill>
+              <a:srgbClr val="0F766E"/>
+            </a:solidFill>
+            <a:prstDash val="solid"/>
+          </a:ln>
+        </p:spPr>
+      </p:sp>
+      <p:pic>
+        <p:nvPicPr>
+          <p:cNvPr id="23" name="Image 5" descr="preencoded.png">    </p:cNvPr>
+          <p:cNvPicPr>
+            <a:picLocks noChangeAspect="1"/>
+          </p:cNvPicPr>
+          <p:nvPr/>
+        </p:nvPicPr>
+        <p:blipFill>
+          <a:blip r:embed="rId7"/>
+          <a:stretch>
+            <a:fillRect/>
+          </a:stretch>
+        </p:blipFill>
+        <p:spPr>
+          <a:xfrm>
+            <a:off x="7763622" y="4947270"/>
+            <a:ext cx="237012" cy="237012"/>
+          </a:xfrm>
+          <a:prstGeom prst="rect">
+            <a:avLst/>
+          </a:prstGeom>
+        </p:spPr>
+      </p:pic>
+      <p:sp>
+        <p:nvSpPr>
+          <p:cNvPr id="24" name="Text 16"/>
+          <p:cNvSpPr txBox="1"/>
+          <p:nvPr/>
+        </p:nvSpPr>
+        <p:spPr>
+          <a:xfrm>
+            <a:off x="8275320" y="4791456"/>
+            <a:ext cx="3383280" cy="292608"/>
+          </a:xfrm>
+          <a:prstGeom prst="rect">
+            <a:avLst/>
+          </a:prstGeom>
+          <a:noFill/>
+          <a:ln/>
+        </p:spPr>
+        <p:txBody>
+          <a:bodyPr wrap="square" lIns="0" tIns="0" rIns="0" bIns="0" rtlCol="0" anchor="t"/>
+          <a:lstStyle/>
+          <a:p>
+            <a:pPr indent="0" marL="0">
+              <a:buNone/>
+            </a:pPr>
+            <a:r>
+              <a:rPr lang="en-US" sz="1500" b="1" dirty="0">
+                <a:solidFill>
+                  <a:srgbClr val="132828"/>
+                </a:solidFill>
+                <a:latin typeface="Arial" pitchFamily="34" charset="0"/>
+                <a:ea typeface="Arial" pitchFamily="34" charset="-122"/>
+                <a:cs typeface="Arial" pitchFamily="34" charset="-120"/>
+              </a:rPr>
+              <a:t>5. Save All</a:t>
+            </a:r>
+            <a:endParaRPr lang="en-US" sz="1500" dirty="0"/>
+          </a:p>
+        </p:txBody>
+      </p:sp>
+      <p:sp>
+        <p:nvSpPr>
+          <p:cNvPr id="25" name="Text 17"/>
+          <p:cNvSpPr txBox="1"/>
+          <p:nvPr/>
+        </p:nvSpPr>
+        <p:spPr>
+          <a:xfrm>
+            <a:off x="8275320" y="5074920"/>
+            <a:ext cx="3383280" cy="411480"/>
+          </a:xfrm>
+          <a:prstGeom prst="rect">
+            <a:avLst/>
+          </a:prstGeom>
+          <a:noFill/>
+          <a:ln/>
+        </p:spPr>
+        <p:txBody>
+          <a:bodyPr wrap="square" lIns="0" tIns="0" rIns="0" bIns="0" rtlCol="0" anchor="t"/>
+          <a:lstStyle/>
+          <a:p>
+            <a:pPr indent="0" marL="0">
+              <a:buNone/>
+            </a:pPr>
+            <a:r>
+              <a:rPr lang="en-US" sz="1250" dirty="0">
+                <a:solidFill>
+                  <a:srgbClr val="5B6B6B"/>
+                </a:solidFill>
+                <a:latin typeface="Calibri" pitchFamily="34" charset="0"/>
+                <a:ea typeface="Calibri" pitchFamily="34" charset="-122"/>
+                <a:cs typeface="Calibri" pitchFamily="34" charset="-120"/>
+              </a:rPr>
+              <a:t>Every row is checked before anything is saved.</a:t>
+            </a:r>
+            <a:endParaRPr lang="en-US" sz="1250" dirty="0"/>
+          </a:p>
+        </p:txBody>
+      </p:sp>
+      <p:sp>
+        <p:nvSpPr>
+          <p:cNvPr id="26" name="Text 18"/>
+          <p:cNvSpPr txBox="1"/>
+          <p:nvPr/>
+        </p:nvSpPr>
+        <p:spPr>
+          <a:xfrm>
+            <a:off x="548640" y="6446520"/>
+            <a:ext cx="5486400" cy="274320"/>
+          </a:xfrm>
+          <a:prstGeom prst="rect">
+            <a:avLst/>
+          </a:prstGeom>
+          <a:noFill/>
+          <a:ln/>
+        </p:spPr>
+        <p:txBody>
+          <a:bodyPr wrap="square" lIns="0" tIns="0" rIns="0" bIns="0" rtlCol="0" anchor="ctr"/>
+          <a:lstStyle/>
+          <a:p>
+            <a:pPr indent="0" marL="0">
+              <a:buNone/>
+            </a:pPr>
+            <a:r>
+              <a:rPr lang="en-US" sz="1000" dirty="0">
+                <a:solidFill>
+                  <a:srgbClr val="8A9A98"/>
+                </a:solidFill>
+                <a:latin typeface="Calibri" pitchFamily="34" charset="0"/>
+                <a:ea typeface="Calibri" pitchFamily="34" charset="-122"/>
+                <a:cs typeface="Calibri" pitchFamily="34" charset="-120"/>
+              </a:rPr>
+              <a:t>SmartDDR v3 · DDR Dashboard · DDR Developer</a:t>
+            </a:r>
+            <a:endParaRPr lang="en-US" sz="1000" dirty="0"/>
+          </a:p>
+        </p:txBody>
+      </p:sp>
+      <p:sp>
+        <p:nvSpPr>
+          <p:cNvPr id="27" name="Text 19"/>
+          <p:cNvSpPr txBox="1"/>
+          <p:nvPr/>
+        </p:nvSpPr>
+        <p:spPr>
+          <a:xfrm>
+            <a:off x="11064240" y="6446520"/>
+            <a:ext cx="576072" cy="274320"/>
+          </a:xfrm>
+          <a:prstGeom prst="rect">
+            <a:avLst/>
+          </a:prstGeom>
+          <a:noFill/>
+          <a:ln/>
+        </p:spPr>
+        <p:txBody>
+          <a:bodyPr wrap="square" lIns="0" tIns="0" rIns="0" bIns="0" rtlCol="0" anchor="ctr"/>
+          <a:lstStyle/>
+          <a:p>
+            <a:pPr algn="r" indent="0" marL="0">
+              <a:buNone/>
+            </a:pPr>
+            <a:r>
+              <a:rPr lang="en-US" sz="1000" dirty="0">
+                <a:solidFill>
+                  <a:srgbClr val="8A9A98"/>
+                </a:solidFill>
+                <a:latin typeface="Calibri" pitchFamily="34" charset="0"/>
+                <a:ea typeface="Calibri" pitchFamily="34" charset="-122"/>
+                <a:cs typeface="Calibri" pitchFamily="34" charset="-120"/>
+              </a:rPr>
+              <a:t>18</a:t>
+            </a:r>
+            <a:endParaRPr lang="en-US" sz="1000" dirty="0"/>
+          </a:p>
+        </p:txBody>
+      </p:sp>
+    </p:spTree>
+  </p:cSld>
+  <p:clrMapOvr>
+    <a:masterClrMapping/>
+  </p:clrMapOvr>
+</p:sld>
+</file>
+
+<file path=ppt/slides/slide19.xml><?xml version="1.0" encoding="utf-8"?>
+<p:sld xmlns:a="http://schemas.openxmlformats.org/drawingml/2006/main" xmlns:r="http://schemas.openxmlformats.org/officeDocument/2006/relationships" xmlns:p="http://schemas.openxmlformats.org/presentationml/2006/main">
+  <p:cSld name="Slide 19">
+    <p:bg>
+      <p:bgPr>
+        <a:blipFill dpi="0" rotWithShape="1">
+          <a:blip r:embed="rId1">
+            <a:lum/>
+          </a:blip>
+          <a:srcRect/>
+          <a:stretch>
+            <a:fillRect/>
+          </a:stretch>
+        </a:blipFill>
+        <a:effectLst/>
+      </p:bgPr>
+    </p:bg>
+    <p:spTree>
+      <p:nvGrpSpPr>
+        <p:cNvPr id="1" name=""/>
+        <p:cNvGrpSpPr/>
+        <p:nvPr/>
+      </p:nvGrpSpPr>
+      <p:grpSpPr>
+        <a:xfrm>
+          <a:off x="0" y="0"/>
+          <a:ext cx="0" cy="0"/>
+          <a:chOff x="0" y="0"/>
+          <a:chExt cx="0" cy="0"/>
+        </a:xfrm>
+      </p:grpSpPr>
+      <p:sp>
+        <p:nvSpPr>
+          <p:cNvPr id="2" name="Text 0"/>
+          <p:cNvSpPr txBox="1"/>
+          <p:nvPr/>
+        </p:nvSpPr>
+        <p:spPr>
+          <a:xfrm>
+            <a:off x="548640" y="365760"/>
+            <a:ext cx="11064240" cy="685800"/>
+          </a:xfrm>
+          <a:prstGeom prst="rect">
+            <a:avLst/>
+          </a:prstGeom>
+          <a:noFill/>
+          <a:ln/>
+        </p:spPr>
+        <p:txBody>
+          <a:bodyPr wrap="square" lIns="0" tIns="0" rIns="0" bIns="0" rtlCol="0" anchor="ctr"/>
+          <a:lstStyle/>
+          <a:p>
+            <a:pPr indent="0" marL="0">
+              <a:buNone/>
+            </a:pPr>
+            <a:r>
+              <a:rPr lang="en-US" sz="3200" b="1" dirty="0">
+                <a:solidFill>
+                  <a:srgbClr val="132828"/>
+                </a:solidFill>
+                <a:latin typeface="Arial" pitchFamily="34" charset="0"/>
+                <a:ea typeface="Arial" pitchFamily="34" charset="-122"/>
+                <a:cs typeface="Arial" pitchFamily="34" charset="-120"/>
+              </a:rPr>
+              <a:t>Less typing, fewer mistakes</a:t>
+            </a:r>
+            <a:endParaRPr lang="en-US" sz="3200" dirty="0"/>
+          </a:p>
+        </p:txBody>
+      </p:sp>
+      <p:sp>
+        <p:nvSpPr>
+          <p:cNvPr id="3" name="Text 1"/>
+          <p:cNvSpPr txBox="1"/>
+          <p:nvPr/>
+        </p:nvSpPr>
+        <p:spPr>
+          <a:xfrm>
+            <a:off x="548640" y="1051560"/>
+            <a:ext cx="11064240" cy="411480"/>
+          </a:xfrm>
+          <a:prstGeom prst="rect">
+            <a:avLst/>
+          </a:prstGeom>
+          <a:noFill/>
+          <a:ln/>
+        </p:spPr>
+        <p:txBody>
+          <a:bodyPr wrap="square" lIns="0" tIns="0" rIns="0" bIns="0" rtlCol="0" anchor="ctr"/>
+          <a:lstStyle/>
+          <a:p>
+            <a:pPr indent="0" marL="0">
+              <a:buNone/>
+            </a:pPr>
+            <a:r>
+              <a:rPr lang="en-US" sz="1600" dirty="0">
+                <a:solidFill>
+                  <a:srgbClr val="5B6B6B"/>
+                </a:solidFill>
+                <a:latin typeface="Calibri" pitchFamily="34" charset="0"/>
+                <a:ea typeface="Calibri" pitchFamily="34" charset="-122"/>
+                <a:cs typeface="Calibri" pitchFamily="34" charset="-120"/>
+              </a:rPr>
+              <a:t>New tools in the latest DDR Developer</a:t>
+            </a:r>
+            <a:endParaRPr lang="en-US" sz="1600" dirty="0"/>
+          </a:p>
+        </p:txBody>
+      </p:sp>
+      <p:sp>
+        <p:nvSpPr>
+          <p:cNvPr id="4" name="Shape 2"/>
+          <p:cNvSpPr/>
+          <p:nvPr/>
+        </p:nvSpPr>
+        <p:spPr>
+          <a:xfrm>
+            <a:off x="5138928" y="1709928"/>
+            <a:ext cx="6547104" cy="3746754"/>
+          </a:xfrm>
+          <a:prstGeom prst="roundRect">
+            <a:avLst>
+              <a:gd name="adj" fmla="val 2441"/>
+            </a:avLst>
+          </a:prstGeom>
+          <a:solidFill>
+            <a:srgbClr val="FFFFFF"/>
+          </a:solidFill>
+          <a:ln w="9525">
+            <a:solidFill>
+              <a:srgbClr val="D5E6E2"/>
+            </a:solidFill>
+            <a:prstDash val="solid"/>
+          </a:ln>
+          <a:effectLst>
+            <a:outerShdw sx="100000" sy="100000" kx="0" ky="0" algn="bl" rotWithShape="0" blurRad="177800" dist="50800" dir="5400000">
+              <a:srgbClr val="0B2B28">
+                <a:alpha val="22000"/>
+              </a:srgbClr>
+            </a:outerShdw>
+          </a:effectLst>
+        </p:spPr>
+      </p:sp>
+      <p:pic>
+        <p:nvPicPr>
+          <p:cNvPr id="5" name="Image 0" descr="/tmp/claude-0/-home-user-BlazerTest/4e1a4774-871d-567d-86ff-c2c6a1597caf/scratchpad/deck/img/dev_drawers.jpg">    </p:cNvPr>
+          <p:cNvPicPr>
+            <a:picLocks noChangeAspect="1"/>
+          </p:cNvPicPr>
+          <p:nvPr/>
+        </p:nvPicPr>
+        <p:blipFill>
+          <a:blip r:embed="rId2"/>
+          <a:stretch>
+            <a:fillRect/>
+          </a:stretch>
+        </p:blipFill>
+        <p:spPr>
+          <a:xfrm>
+            <a:off x="5212080" y="1783080"/>
+            <a:ext cx="6400800" cy="3600450"/>
+          </a:xfrm>
+          <a:prstGeom prst="rect">
+            <a:avLst/>
+          </a:prstGeom>
+        </p:spPr>
+      </p:pic>
+      <p:sp>
+        <p:nvSpPr>
+          <p:cNvPr id="6" name="Shape 3"/>
+          <p:cNvSpPr/>
+          <p:nvPr/>
+        </p:nvSpPr>
+        <p:spPr>
+          <a:xfrm>
+            <a:off x="548640" y="1783080"/>
+            <a:ext cx="493776" cy="493776"/>
+          </a:xfrm>
+          <a:prstGeom prst="ellipse">
+            <a:avLst/>
+          </a:prstGeom>
+          <a:solidFill>
+            <a:srgbClr val="0F766E"/>
+          </a:solidFill>
+          <a:ln w="12700">
+            <a:solidFill>
+              <a:srgbClr val="0F766E"/>
+            </a:solidFill>
+            <a:prstDash val="solid"/>
+          </a:ln>
+        </p:spPr>
+      </p:sp>
+      <p:pic>
+        <p:nvPicPr>
+          <p:cNvPr id="7" name="Image 1" descr="preencoded.png">    </p:cNvPr>
+          <p:cNvPicPr>
+            <a:picLocks noChangeAspect="1"/>
+          </p:cNvPicPr>
+          <p:nvPr/>
+        </p:nvPicPr>
+        <p:blipFill>
+          <a:blip r:embed="rId3"/>
+          <a:stretch>
+            <a:fillRect/>
+          </a:stretch>
+        </p:blipFill>
+        <p:spPr>
+          <a:xfrm>
+            <a:off x="677022" y="1911462"/>
+            <a:ext cx="237012" cy="237012"/>
+          </a:xfrm>
+          <a:prstGeom prst="rect">
+            <a:avLst/>
+          </a:prstGeom>
+        </p:spPr>
+      </p:pic>
+      <p:sp>
+        <p:nvSpPr>
+          <p:cNvPr id="8" name="Text 4"/>
+          <p:cNvSpPr txBox="1"/>
+          <p:nvPr/>
+        </p:nvSpPr>
+        <p:spPr>
+          <a:xfrm>
+            <a:off x="1188720" y="1755648"/>
+            <a:ext cx="3749040" cy="292608"/>
+          </a:xfrm>
+          <a:prstGeom prst="rect">
+            <a:avLst/>
+          </a:prstGeom>
+          <a:noFill/>
+          <a:ln/>
+        </p:spPr>
+        <p:txBody>
+          <a:bodyPr wrap="square" lIns="0" tIns="0" rIns="0" bIns="0" rtlCol="0" anchor="t"/>
+          <a:lstStyle/>
+          <a:p>
+            <a:pPr indent="0" marL="0">
+              <a:buNone/>
+            </a:pPr>
+            <a:r>
+              <a:rPr lang="en-US" sz="1500" b="1" dirty="0">
+                <a:solidFill>
+                  <a:srgbClr val="132828"/>
+                </a:solidFill>
+                <a:latin typeface="Arial" pitchFamily="34" charset="0"/>
+                <a:ea typeface="Arial" pitchFamily="34" charset="-122"/>
+                <a:cs typeface="Arial" pitchFamily="34" charset="-120"/>
+              </a:rPr>
+              <a:t>DDR Multiplier</a:t>
+            </a:r>
+            <a:endParaRPr lang="en-US" sz="1500" dirty="0"/>
+          </a:p>
+        </p:txBody>
+      </p:sp>
+      <p:sp>
+        <p:nvSpPr>
+          <p:cNvPr id="9" name="Text 5"/>
+          <p:cNvSpPr txBox="1"/>
+          <p:nvPr/>
+        </p:nvSpPr>
+        <p:spPr>
+          <a:xfrm>
+            <a:off x="1188720" y="2048256"/>
+            <a:ext cx="3749040" cy="502920"/>
+          </a:xfrm>
+          <a:prstGeom prst="rect">
+            <a:avLst/>
+          </a:prstGeom>
+          <a:noFill/>
+          <a:ln/>
+        </p:spPr>
+        <p:txBody>
+          <a:bodyPr wrap="square" lIns="0" tIns="0" rIns="0" bIns="0" rtlCol="0" anchor="t"/>
+          <a:lstStyle/>
+          <a:p>
+            <a:pPr indent="0" marL="0">
+              <a:buNone/>
+            </a:pPr>
+            <a:r>
+              <a:rPr lang="en-US" sz="1250" dirty="0">
+                <a:solidFill>
+                  <a:srgbClr val="5B6B6B"/>
+                </a:solidFill>
+                <a:latin typeface="Calibri" pitchFamily="34" charset="0"/>
+                <a:ea typeface="Calibri" pitchFamily="34" charset="-122"/>
+                <a:cs typeface="Calibri" pitchFamily="34" charset="-120"/>
+              </a:rPr>
+              <a:t>Copy a row N times, with the next DUM number or the next document number.</a:t>
+            </a:r>
+            <a:endParaRPr lang="en-US" sz="1250" dirty="0"/>
+          </a:p>
+        </p:txBody>
+      </p:sp>
+      <p:sp>
+        <p:nvSpPr>
+          <p:cNvPr id="10" name="Shape 6"/>
+          <p:cNvSpPr/>
+          <p:nvPr/>
+        </p:nvSpPr>
+        <p:spPr>
+          <a:xfrm>
+            <a:off x="548640" y="2651760"/>
+            <a:ext cx="493776" cy="493776"/>
+          </a:xfrm>
+          <a:prstGeom prst="ellipse">
+            <a:avLst/>
+          </a:prstGeom>
+          <a:solidFill>
+            <a:srgbClr val="0F766E"/>
+          </a:solidFill>
+          <a:ln w="12700">
+            <a:solidFill>
+              <a:srgbClr val="0F766E"/>
+            </a:solidFill>
+            <a:prstDash val="solid"/>
+          </a:ln>
+        </p:spPr>
+      </p:sp>
+      <p:pic>
+        <p:nvPicPr>
+          <p:cNvPr id="11" name="Image 2" descr="preencoded.png">    </p:cNvPr>
+          <p:cNvPicPr>
+            <a:picLocks noChangeAspect="1"/>
+          </p:cNvPicPr>
+          <p:nvPr/>
+        </p:nvPicPr>
+        <p:blipFill>
+          <a:blip r:embed="rId4"/>
+          <a:stretch>
+            <a:fillRect/>
+          </a:stretch>
+        </p:blipFill>
+        <p:spPr>
+          <a:xfrm>
+            <a:off x="677022" y="2780142"/>
+            <a:ext cx="237012" cy="237012"/>
+          </a:xfrm>
+          <a:prstGeom prst="rect">
+            <a:avLst/>
+          </a:prstGeom>
+        </p:spPr>
+      </p:pic>
+      <p:sp>
+        <p:nvSpPr>
+          <p:cNvPr id="12" name="Text 7"/>
+          <p:cNvSpPr txBox="1"/>
+          <p:nvPr/>
+        </p:nvSpPr>
+        <p:spPr>
+          <a:xfrm>
+            <a:off x="1188720" y="2624328"/>
+            <a:ext cx="3749040" cy="292608"/>
+          </a:xfrm>
+          <a:prstGeom prst="rect">
+            <a:avLst/>
+          </a:prstGeom>
+          <a:noFill/>
+          <a:ln/>
+        </p:spPr>
+        <p:txBody>
+          <a:bodyPr wrap="square" lIns="0" tIns="0" rIns="0" bIns="0" rtlCol="0" anchor="t"/>
+          <a:lstStyle/>
+          <a:p>
+            <a:pPr indent="0" marL="0">
+              <a:buNone/>
+            </a:pPr>
+            <a:r>
+              <a:rPr lang="en-US" sz="1500" b="1" dirty="0">
+                <a:solidFill>
+                  <a:srgbClr val="132828"/>
+                </a:solidFill>
+                <a:latin typeface="Arial" pitchFamily="34" charset="0"/>
+                <a:ea typeface="Arial" pitchFamily="34" charset="-122"/>
+                <a:cs typeface="Arial" pitchFamily="34" charset="-120"/>
+              </a:rPr>
+              <a:t>Smart dummy numbers</a:t>
+            </a:r>
+            <a:endParaRPr lang="en-US" sz="1500" dirty="0"/>
+          </a:p>
+        </p:txBody>
+      </p:sp>
+      <p:sp>
+        <p:nvSpPr>
+          <p:cNvPr id="13" name="Text 8"/>
+          <p:cNvSpPr txBox="1"/>
+          <p:nvPr/>
+        </p:nvSpPr>
+        <p:spPr>
+          <a:xfrm>
+            <a:off x="1188720" y="2916936"/>
+            <a:ext cx="3749040" cy="502920"/>
+          </a:xfrm>
+          <a:prstGeom prst="rect">
+            <a:avLst/>
+          </a:prstGeom>
+          <a:noFill/>
+          <a:ln/>
+        </p:spPr>
+        <p:txBody>
+          <a:bodyPr wrap="square" lIns="0" tIns="0" rIns="0" bIns="0" rtlCol="0" anchor="t"/>
+          <a:lstStyle/>
+          <a:p>
+            <a:pPr indent="0" marL="0">
+              <a:buNone/>
+            </a:pPr>
+            <a:r>
+              <a:rPr lang="en-US" sz="1250" dirty="0">
+                <a:solidFill>
+                  <a:srgbClr val="5B6B6B"/>
+                </a:solidFill>
+                <a:latin typeface="Calibri" pitchFamily="34" charset="0"/>
+                <a:ea typeface="Calibri" pitchFamily="34" charset="-122"/>
+                <a:cs typeface="Calibri" pitchFamily="34" charset="-120"/>
+              </a:rPr>
+              <a:t>DUM01…DUM99, then DU100+, never a flat "DUMMY".</a:t>
+            </a:r>
+            <a:endParaRPr lang="en-US" sz="1250" dirty="0"/>
+          </a:p>
+        </p:txBody>
+      </p:sp>
+      <p:sp>
+        <p:nvSpPr>
+          <p:cNvPr id="14" name="Shape 9"/>
+          <p:cNvSpPr/>
+          <p:nvPr/>
+        </p:nvSpPr>
+        <p:spPr>
+          <a:xfrm>
+            <a:off x="548640" y="3520440"/>
+            <a:ext cx="493776" cy="493776"/>
+          </a:xfrm>
+          <a:prstGeom prst="ellipse">
+            <a:avLst/>
+          </a:prstGeom>
+          <a:solidFill>
+            <a:srgbClr val="0F766E"/>
+          </a:solidFill>
+          <a:ln w="12700">
+            <a:solidFill>
+              <a:srgbClr val="0F766E"/>
+            </a:solidFill>
+            <a:prstDash val="solid"/>
+          </a:ln>
+        </p:spPr>
+      </p:sp>
+      <p:pic>
+        <p:nvPicPr>
+          <p:cNvPr id="15" name="Image 3" descr="preencoded.png">    </p:cNvPr>
+          <p:cNvPicPr>
+            <a:picLocks noChangeAspect="1"/>
+          </p:cNvPicPr>
+          <p:nvPr/>
+        </p:nvPicPr>
+        <p:blipFill>
+          <a:blip r:embed="rId5"/>
+          <a:stretch>
+            <a:fillRect/>
+          </a:stretch>
+        </p:blipFill>
+        <p:spPr>
+          <a:xfrm>
+            <a:off x="677022" y="3648822"/>
+            <a:ext cx="237012" cy="237012"/>
+          </a:xfrm>
+          <a:prstGeom prst="rect">
+            <a:avLst/>
+          </a:prstGeom>
+        </p:spPr>
+      </p:pic>
+      <p:sp>
+        <p:nvSpPr>
+          <p:cNvPr id="16" name="Text 10"/>
+          <p:cNvSpPr txBox="1"/>
+          <p:nvPr/>
+        </p:nvSpPr>
+        <p:spPr>
+          <a:xfrm>
+            <a:off x="1188720" y="3493008"/>
+            <a:ext cx="3749040" cy="292608"/>
+          </a:xfrm>
+          <a:prstGeom prst="rect">
+            <a:avLst/>
+          </a:prstGeom>
+          <a:noFill/>
+          <a:ln/>
+        </p:spPr>
+        <p:txBody>
+          <a:bodyPr wrap="square" lIns="0" tIns="0" rIns="0" bIns="0" rtlCol="0" anchor="t"/>
+          <a:lstStyle/>
+          <a:p>
+            <a:pPr indent="0" marL="0">
+              <a:buNone/>
+            </a:pPr>
+            <a:r>
+              <a:rPr lang="en-US" sz="1500" b="1" dirty="0">
+                <a:solidFill>
+                  <a:srgbClr val="132828"/>
+                </a:solidFill>
+                <a:latin typeface="Arial" pitchFamily="34" charset="0"/>
+                <a:ea typeface="Arial" pitchFamily="34" charset="-122"/>
+                <a:cs typeface="Arial" pitchFamily="34" charset="-120"/>
+              </a:rPr>
+              <a:t>Allocate Hours</a:t>
+            </a:r>
+            <a:endParaRPr lang="en-US" sz="1500" dirty="0"/>
+          </a:p>
+        </p:txBody>
+      </p:sp>
+      <p:sp>
+        <p:nvSpPr>
+          <p:cNvPr id="17" name="Text 11"/>
+          <p:cNvSpPr txBox="1"/>
+          <p:nvPr/>
+        </p:nvSpPr>
+        <p:spPr>
+          <a:xfrm>
+            <a:off x="1188720" y="3785616"/>
+            <a:ext cx="3749040" cy="502920"/>
+          </a:xfrm>
+          <a:prstGeom prst="rect">
+            <a:avLst/>
+          </a:prstGeom>
+          <a:noFill/>
+          <a:ln/>
+        </p:spPr>
+        <p:txBody>
+          <a:bodyPr wrap="square" lIns="0" tIns="0" rIns="0" bIns="0" rtlCol="0" anchor="t"/>
+          <a:lstStyle/>
+          <a:p>
+            <a:pPr indent="0" marL="0">
+              <a:buNone/>
+            </a:pPr>
+            <a:r>
+              <a:rPr lang="en-US" sz="1250" dirty="0">
+                <a:solidFill>
+                  <a:srgbClr val="5B6B6B"/>
+                </a:solidFill>
+                <a:latin typeface="Calibri" pitchFamily="34" charset="0"/>
+                <a:ea typeface="Calibri" pitchFamily="34" charset="-122"/>
+                <a:cs typeface="Calibri" pitchFamily="34" charset="-120"/>
+              </a:rPr>
+              <a:t>Even split; rounding goes to the first row.</a:t>
+            </a:r>
+            <a:endParaRPr lang="en-US" sz="1250" dirty="0"/>
+          </a:p>
+        </p:txBody>
+      </p:sp>
+      <p:sp>
+        <p:nvSpPr>
+          <p:cNvPr id="18" name="Shape 12"/>
+          <p:cNvSpPr/>
+          <p:nvPr/>
+        </p:nvSpPr>
+        <p:spPr>
+          <a:xfrm>
+            <a:off x="548640" y="4389120"/>
+            <a:ext cx="493776" cy="493776"/>
+          </a:xfrm>
+          <a:prstGeom prst="ellipse">
+            <a:avLst/>
+          </a:prstGeom>
+          <a:solidFill>
+            <a:srgbClr val="0F766E"/>
+          </a:solidFill>
+          <a:ln w="12700">
+            <a:solidFill>
+              <a:srgbClr val="0F766E"/>
+            </a:solidFill>
+            <a:prstDash val="solid"/>
+          </a:ln>
+        </p:spPr>
+      </p:sp>
+      <p:pic>
+        <p:nvPicPr>
+          <p:cNvPr id="19" name="Image 4" descr="preencoded.png">    </p:cNvPr>
+          <p:cNvPicPr>
+            <a:picLocks noChangeAspect="1"/>
+          </p:cNvPicPr>
+          <p:nvPr/>
+        </p:nvPicPr>
+        <p:blipFill>
+          <a:blip r:embed="rId6"/>
+          <a:stretch>
+            <a:fillRect/>
+          </a:stretch>
+        </p:blipFill>
+        <p:spPr>
+          <a:xfrm>
+            <a:off x="677022" y="4517502"/>
+            <a:ext cx="237012" cy="237012"/>
+          </a:xfrm>
+          <a:prstGeom prst="rect">
+            <a:avLst/>
+          </a:prstGeom>
+        </p:spPr>
+      </p:pic>
+      <p:sp>
+        <p:nvSpPr>
+          <p:cNvPr id="20" name="Text 13"/>
+          <p:cNvSpPr txBox="1"/>
+          <p:nvPr/>
+        </p:nvSpPr>
+        <p:spPr>
+          <a:xfrm>
+            <a:off x="1188720" y="4361688"/>
+            <a:ext cx="3749040" cy="292608"/>
+          </a:xfrm>
+          <a:prstGeom prst="rect">
+            <a:avLst/>
+          </a:prstGeom>
+          <a:noFill/>
+          <a:ln/>
+        </p:spPr>
+        <p:txBody>
+          <a:bodyPr wrap="square" lIns="0" tIns="0" rIns="0" bIns="0" rtlCol="0" anchor="t"/>
+          <a:lstStyle/>
+          <a:p>
+            <a:pPr indent="0" marL="0">
+              <a:buNone/>
+            </a:pPr>
+            <a:r>
+              <a:rPr lang="en-US" sz="1500" b="1" dirty="0">
+                <a:solidFill>
+                  <a:srgbClr val="132828"/>
+                </a:solidFill>
+                <a:latin typeface="Arial" pitchFamily="34" charset="0"/>
+                <a:ea typeface="Arial" pitchFamily="34" charset="-122"/>
+                <a:cs typeface="Arial" pitchFamily="34" charset="-120"/>
+              </a:rPr>
+              <a:t>PLIP details on pick</a:t>
+            </a:r>
+            <a:endParaRPr lang="en-US" sz="1500" dirty="0"/>
+          </a:p>
+        </p:txBody>
+      </p:sp>
+      <p:sp>
+        <p:nvSpPr>
+          <p:cNvPr id="21" name="Text 14"/>
+          <p:cNvSpPr txBox="1"/>
+          <p:nvPr/>
+        </p:nvSpPr>
+        <p:spPr>
+          <a:xfrm>
+            <a:off x="1188720" y="4654296"/>
+            <a:ext cx="3749040" cy="502920"/>
+          </a:xfrm>
+          <a:prstGeom prst="rect">
+            <a:avLst/>
+          </a:prstGeom>
+          <a:noFill/>
+          <a:ln/>
+        </p:spPr>
+        <p:txBody>
+          <a:bodyPr wrap="square" lIns="0" tIns="0" rIns="0" bIns="0" rtlCol="0" anchor="t"/>
+          <a:lstStyle/>
+          <a:p>
+            <a:pPr indent="0" marL="0">
+              <a:buNone/>
+            </a:pPr>
+            <a:r>
+              <a:rPr lang="en-US" sz="1250" dirty="0">
+                <a:solidFill>
+                  <a:srgbClr val="5B6B6B"/>
+                </a:solidFill>
+                <a:latin typeface="Calibri" pitchFamily="34" charset="0"/>
+                <a:ea typeface="Calibri" pitchFamily="34" charset="-122"/>
+                <a:cs typeface="Calibri" pitchFamily="34" charset="-120"/>
+              </a:rPr>
+              <a:t>Title, doc type, critical, HO status, DCAF.</a:t>
+            </a:r>
+            <a:endParaRPr lang="en-US" sz="1250" dirty="0"/>
+          </a:p>
+        </p:txBody>
+      </p:sp>
+      <p:sp>
+        <p:nvSpPr>
+          <p:cNvPr id="22" name="Shape 15"/>
+          <p:cNvSpPr/>
+          <p:nvPr/>
+        </p:nvSpPr>
+        <p:spPr>
+          <a:xfrm>
+            <a:off x="548640" y="5257800"/>
+            <a:ext cx="493776" cy="493776"/>
+          </a:xfrm>
+          <a:prstGeom prst="ellipse">
+            <a:avLst/>
+          </a:prstGeom>
+          <a:solidFill>
+            <a:srgbClr val="0F766E"/>
+          </a:solidFill>
+          <a:ln w="12700">
+            <a:solidFill>
+              <a:srgbClr val="0F766E"/>
+            </a:solidFill>
+            <a:prstDash val="solid"/>
+          </a:ln>
+        </p:spPr>
+      </p:sp>
+      <p:pic>
+        <p:nvPicPr>
+          <p:cNvPr id="23" name="Image 5" descr="preencoded.png">    </p:cNvPr>
+          <p:cNvPicPr>
+            <a:picLocks noChangeAspect="1"/>
+          </p:cNvPicPr>
+          <p:nvPr/>
+        </p:nvPicPr>
+        <p:blipFill>
+          <a:blip r:embed="rId7"/>
+          <a:stretch>
+            <a:fillRect/>
+          </a:stretch>
+        </p:blipFill>
+        <p:spPr>
+          <a:xfrm>
+            <a:off x="677022" y="5386182"/>
+            <a:ext cx="237012" cy="237012"/>
+          </a:xfrm>
+          <a:prstGeom prst="rect">
+            <a:avLst/>
+          </a:prstGeom>
+        </p:spPr>
+      </p:pic>
+      <p:sp>
+        <p:nvSpPr>
+          <p:cNvPr id="24" name="Text 16"/>
+          <p:cNvSpPr txBox="1"/>
+          <p:nvPr/>
+        </p:nvSpPr>
+        <p:spPr>
+          <a:xfrm>
+            <a:off x="1188720" y="5230368"/>
+            <a:ext cx="3749040" cy="292608"/>
+          </a:xfrm>
+          <a:prstGeom prst="rect">
+            <a:avLst/>
+          </a:prstGeom>
+          <a:noFill/>
+          <a:ln/>
+        </p:spPr>
+        <p:txBody>
+          <a:bodyPr wrap="square" lIns="0" tIns="0" rIns="0" bIns="0" rtlCol="0" anchor="t"/>
+          <a:lstStyle/>
+          <a:p>
+            <a:pPr indent="0" marL="0">
+              <a:buNone/>
+            </a:pPr>
+            <a:r>
+              <a:rPr lang="en-US" sz="1500" b="1" dirty="0">
+                <a:solidFill>
+                  <a:srgbClr val="132828"/>
+                </a:solidFill>
+                <a:latin typeface="Arial" pitchFamily="34" charset="0"/>
+                <a:ea typeface="Arial" pitchFamily="34" charset="-122"/>
+                <a:cs typeface="Arial" pitchFamily="34" charset="-120"/>
+              </a:rPr>
+              <a:t>CSV template and upload</a:t>
+            </a:r>
+            <a:endParaRPr lang="en-US" sz="1500" dirty="0"/>
+          </a:p>
+        </p:txBody>
+      </p:sp>
+      <p:sp>
+        <p:nvSpPr>
+          <p:cNvPr id="25" name="Text 17"/>
+          <p:cNvSpPr txBox="1"/>
+          <p:nvPr/>
+        </p:nvSpPr>
+        <p:spPr>
+          <a:xfrm>
+            <a:off x="1188720" y="5522976"/>
+            <a:ext cx="3749040" cy="502920"/>
+          </a:xfrm>
+          <a:prstGeom prst="rect">
+            <a:avLst/>
+          </a:prstGeom>
+          <a:noFill/>
+          <a:ln/>
+        </p:spPr>
+        <p:txBody>
+          <a:bodyPr wrap="square" lIns="0" tIns="0" rIns="0" bIns="0" rtlCol="0" anchor="t"/>
+          <a:lstStyle/>
+          <a:p>
+            <a:pPr indent="0" marL="0">
+              <a:buNone/>
+            </a:pPr>
+            <a:r>
+              <a:rPr lang="en-US" sz="1250" dirty="0">
+                <a:solidFill>
+                  <a:srgbClr val="5B6B6B"/>
+                </a:solidFill>
+                <a:latin typeface="Calibri" pitchFamily="34" charset="0"/>
+                <a:ea typeface="Calibri" pitchFamily="34" charset="-122"/>
+                <a:cs typeface="Calibri" pitchFamily="34" charset="-120"/>
+              </a:rPr>
+              <a:t>Seven fields, checked row by row in one transaction.</a:t>
+            </a:r>
+            <a:endParaRPr lang="en-US" sz="1250" dirty="0"/>
+          </a:p>
+        </p:txBody>
+      </p:sp>
+      <p:sp>
+        <p:nvSpPr>
+          <p:cNvPr id="26" name="Text 18"/>
+          <p:cNvSpPr txBox="1"/>
+          <p:nvPr/>
+        </p:nvSpPr>
+        <p:spPr>
+          <a:xfrm>
+            <a:off x="548640" y="6446520"/>
+            <a:ext cx="5486400" cy="274320"/>
+          </a:xfrm>
+          <a:prstGeom prst="rect">
+            <a:avLst/>
+          </a:prstGeom>
+          <a:noFill/>
+          <a:ln/>
+        </p:spPr>
+        <p:txBody>
+          <a:bodyPr wrap="square" lIns="0" tIns="0" rIns="0" bIns="0" rtlCol="0" anchor="ctr"/>
+          <a:lstStyle/>
+          <a:p>
+            <a:pPr indent="0" marL="0">
+              <a:buNone/>
+            </a:pPr>
+            <a:r>
+              <a:rPr lang="en-US" sz="1000" dirty="0">
+                <a:solidFill>
+                  <a:srgbClr val="8A9A98"/>
+                </a:solidFill>
+                <a:latin typeface="Calibri" pitchFamily="34" charset="0"/>
+                <a:ea typeface="Calibri" pitchFamily="34" charset="-122"/>
+                <a:cs typeface="Calibri" pitchFamily="34" charset="-120"/>
+              </a:rPr>
+              <a:t>SmartDDR v3 · DDR Dashboard · DDR Developer</a:t>
+            </a:r>
+            <a:endParaRPr lang="en-US" sz="1000" dirty="0"/>
+          </a:p>
+        </p:txBody>
+      </p:sp>
+      <p:sp>
+        <p:nvSpPr>
+          <p:cNvPr id="27" name="Text 19"/>
+          <p:cNvSpPr txBox="1"/>
+          <p:nvPr/>
+        </p:nvSpPr>
+        <p:spPr>
+          <a:xfrm>
+            <a:off x="11064240" y="6446520"/>
+            <a:ext cx="576072" cy="274320"/>
+          </a:xfrm>
+          <a:prstGeom prst="rect">
+            <a:avLst/>
+          </a:prstGeom>
+          <a:noFill/>
+          <a:ln/>
+        </p:spPr>
+        <p:txBody>
+          <a:bodyPr wrap="square" lIns="0" tIns="0" rIns="0" bIns="0" rtlCol="0" anchor="ctr"/>
+          <a:lstStyle/>
+          <a:p>
+            <a:pPr algn="r" indent="0" marL="0">
+              <a:buNone/>
+            </a:pPr>
+            <a:r>
+              <a:rPr lang="en-US" sz="1000" dirty="0">
+                <a:solidFill>
+                  <a:srgbClr val="8A9A98"/>
+                </a:solidFill>
+                <a:latin typeface="Calibri" pitchFamily="34" charset="0"/>
+                <a:ea typeface="Calibri" pitchFamily="34" charset="-122"/>
+                <a:cs typeface="Calibri" pitchFamily="34" charset="-120"/>
+              </a:rPr>
+              <a:t>19</a:t>
+            </a:r>
+            <a:endParaRPr lang="en-US" sz="1000" dirty="0"/>
+          </a:p>
+        </p:txBody>
+      </p:sp>
     </p:spTree>
   </p:cSld>
   <p:clrMapOvr>
@@ -9399,7 +11296,7 @@
                 <a:ea typeface="Calibri" pitchFamily="34" charset="-122"/>
                 <a:cs typeface="Calibri" pitchFamily="34" charset="-120"/>
               </a:rPr>
-              <a:t>SmartDDR v3 · DDR Dashboard</a:t>
+              <a:t>SmartDDR v3 · DDR Dashboard · DDR Developer</a:t>
             </a:r>
             <a:endParaRPr lang="en-US" sz="1000" dirty="0"/>
           </a:p>
@@ -9444,6 +11341,1453 @@
           </a:p>
         </p:txBody>
       </p:sp>
+    </p:spTree>
+  </p:cSld>
+  <p:clrMapOvr>
+    <a:masterClrMapping/>
+  </p:clrMapOvr>
+</p:sld>
+</file>
+
+<file path=ppt/slides/slide20.xml><?xml version="1.0" encoding="utf-8"?>
+<p:sld xmlns:a="http://schemas.openxmlformats.org/drawingml/2006/main" xmlns:r="http://schemas.openxmlformats.org/officeDocument/2006/relationships" xmlns:p="http://schemas.openxmlformats.org/presentationml/2006/main">
+  <p:cSld name="Slide 20">
+    <p:bg>
+      <p:bgPr>
+        <a:blipFill dpi="0" rotWithShape="1">
+          <a:blip r:embed="rId1">
+            <a:lum/>
+          </a:blip>
+          <a:srcRect/>
+          <a:stretch>
+            <a:fillRect/>
+          </a:stretch>
+        </a:blipFill>
+        <a:effectLst/>
+      </p:bgPr>
+    </p:bg>
+    <p:spTree>
+      <p:nvGrpSpPr>
+        <p:cNvPr id="1" name=""/>
+        <p:cNvGrpSpPr/>
+        <p:nvPr/>
+      </p:nvGrpSpPr>
+      <p:grpSpPr>
+        <a:xfrm>
+          <a:off x="0" y="0"/>
+          <a:ext cx="0" cy="0"/>
+          <a:chOff x="0" y="0"/>
+          <a:chExt cx="0" cy="0"/>
+        </a:xfrm>
+      </p:grpSpPr>
+      <p:sp>
+        <p:nvSpPr>
+          <p:cNvPr id="2" name="Text 0"/>
+          <p:cNvSpPr txBox="1"/>
+          <p:nvPr/>
+        </p:nvSpPr>
+        <p:spPr>
+          <a:xfrm>
+            <a:off x="548640" y="365760"/>
+            <a:ext cx="11064240" cy="685800"/>
+          </a:xfrm>
+          <a:prstGeom prst="rect">
+            <a:avLst/>
+          </a:prstGeom>
+          <a:noFill/>
+          <a:ln/>
+        </p:spPr>
+        <p:txBody>
+          <a:bodyPr wrap="square" lIns="0" tIns="0" rIns="0" bIns="0" rtlCol="0" anchor="ctr"/>
+          <a:lstStyle/>
+          <a:p>
+            <a:pPr indent="0" marL="0">
+              <a:buNone/>
+            </a:pPr>
+            <a:r>
+              <a:rPr lang="en-US" sz="3200" b="1" dirty="0">
+                <a:solidFill>
+                  <a:srgbClr val="132828"/>
+                </a:solidFill>
+                <a:latin typeface="Arial" pitchFamily="34" charset="0"/>
+                <a:ea typeface="Arial" pitchFamily="34" charset="-122"/>
+                <a:cs typeface="Arial" pitchFamily="34" charset="-120"/>
+              </a:rPr>
+              <a:t>Rebuilt to be reliable</a:t>
+            </a:r>
+            <a:endParaRPr lang="en-US" sz="3200" dirty="0"/>
+          </a:p>
+        </p:txBody>
+      </p:sp>
+      <p:sp>
+        <p:nvSpPr>
+          <p:cNvPr id="3" name="Text 1"/>
+          <p:cNvSpPr txBox="1"/>
+          <p:nvPr/>
+        </p:nvSpPr>
+        <p:spPr>
+          <a:xfrm>
+            <a:off x="548640" y="1051560"/>
+            <a:ext cx="11064240" cy="411480"/>
+          </a:xfrm>
+          <a:prstGeom prst="rect">
+            <a:avLst/>
+          </a:prstGeom>
+          <a:noFill/>
+          <a:ln/>
+        </p:spPr>
+        <p:txBody>
+          <a:bodyPr wrap="square" lIns="0" tIns="0" rIns="0" bIns="0" rtlCol="0" anchor="ctr"/>
+          <a:lstStyle/>
+          <a:p>
+            <a:pPr indent="0" marL="0">
+              <a:buNone/>
+            </a:pPr>
+            <a:r>
+              <a:rPr lang="en-US" sz="1600" dirty="0">
+                <a:solidFill>
+                  <a:srgbClr val="5B6B6B"/>
+                </a:solidFill>
+                <a:latin typeface="Calibri" pitchFamily="34" charset="0"/>
+                <a:ea typeface="Calibri" pitchFamily="34" charset="-122"/>
+                <a:cs typeface="Calibri" pitchFamily="34" charset="-120"/>
+              </a:rPr>
+              <a:t>The page was audited end to end; problems in the original were fixed, not worked around</a:t>
+            </a:r>
+            <a:endParaRPr lang="en-US" sz="1600" dirty="0"/>
+          </a:p>
+        </p:txBody>
+      </p:sp>
+      <p:sp>
+        <p:nvSpPr>
+          <p:cNvPr id="4" name="Shape 2"/>
+          <p:cNvSpPr/>
+          <p:nvPr/>
+        </p:nvSpPr>
+        <p:spPr>
+          <a:xfrm>
+            <a:off x="548640" y="1783080"/>
+            <a:ext cx="3108960" cy="1188720"/>
+          </a:xfrm>
+          <a:prstGeom prst="roundRect">
+            <a:avLst>
+              <a:gd name="adj" fmla="val 9231"/>
+            </a:avLst>
+          </a:prstGeom>
+          <a:solidFill>
+            <a:srgbClr val="FFFFFF"/>
+          </a:solidFill>
+          <a:ln w="9525">
+            <a:solidFill>
+              <a:srgbClr val="D5E6E2"/>
+            </a:solidFill>
+            <a:prstDash val="solid"/>
+          </a:ln>
+          <a:effectLst>
+            <a:outerShdw sx="100000" sy="100000" kx="0" ky="0" algn="bl" rotWithShape="0" blurRad="127000" dist="25400" dir="5400000">
+              <a:srgbClr val="0B2B28">
+                <a:alpha val="12000"/>
+              </a:srgbClr>
+            </a:outerShdw>
+          </a:effectLst>
+        </p:spPr>
+      </p:sp>
+      <p:sp>
+        <p:nvSpPr>
+          <p:cNvPr id="5" name="Text 3"/>
+          <p:cNvSpPr txBox="1"/>
+          <p:nvPr/>
+        </p:nvSpPr>
+        <p:spPr>
+          <a:xfrm>
+            <a:off x="777240" y="1874520"/>
+            <a:ext cx="1005840" cy="1005840"/>
+          </a:xfrm>
+          <a:prstGeom prst="rect">
+            <a:avLst/>
+          </a:prstGeom>
+          <a:noFill/>
+          <a:ln/>
+        </p:spPr>
+        <p:txBody>
+          <a:bodyPr wrap="square" lIns="0" tIns="0" rIns="0" bIns="0" rtlCol="0" anchor="ctr"/>
+          <a:lstStyle/>
+          <a:p>
+            <a:pPr indent="0" marL="0">
+              <a:buNone/>
+            </a:pPr>
+            <a:r>
+              <a:rPr lang="en-US" sz="4000" b="1" dirty="0">
+                <a:solidFill>
+                  <a:srgbClr val="0F766E"/>
+                </a:solidFill>
+                <a:latin typeface="Arial" pitchFamily="34" charset="0"/>
+                <a:ea typeface="Arial" pitchFamily="34" charset="-122"/>
+                <a:cs typeface="Arial" pitchFamily="34" charset="-120"/>
+              </a:rPr>
+              <a:t>18</a:t>
+            </a:r>
+            <a:endParaRPr lang="en-US" sz="4000" dirty="0"/>
+          </a:p>
+        </p:txBody>
+      </p:sp>
+      <p:sp>
+        <p:nvSpPr>
+          <p:cNvPr id="6" name="Text 4"/>
+          <p:cNvSpPr txBox="1"/>
+          <p:nvPr/>
+        </p:nvSpPr>
+        <p:spPr>
+          <a:xfrm>
+            <a:off x="1783080" y="1874520"/>
+            <a:ext cx="1737360" cy="1005840"/>
+          </a:xfrm>
+          <a:prstGeom prst="rect">
+            <a:avLst/>
+          </a:prstGeom>
+          <a:noFill/>
+          <a:ln/>
+        </p:spPr>
+        <p:txBody>
+          <a:bodyPr wrap="square" lIns="0" tIns="0" rIns="0" bIns="0" rtlCol="0" anchor="ctr"/>
+          <a:lstStyle/>
+          <a:p>
+            <a:pPr indent="0" marL="0">
+              <a:buNone/>
+            </a:pPr>
+            <a:r>
+              <a:rPr lang="en-US" sz="1300" dirty="0">
+                <a:solidFill>
+                  <a:srgbClr val="5B6B6B"/>
+                </a:solidFill>
+                <a:latin typeface="Calibri" pitchFamily="34" charset="0"/>
+                <a:ea typeface="Calibri" pitchFamily="34" charset="-122"/>
+                <a:cs typeface="Calibri" pitchFamily="34" charset="-120"/>
+              </a:rPr>
+              <a:t>bugs fixed, including a page crash</a:t>
+            </a:r>
+            <a:endParaRPr lang="en-US" sz="1300" dirty="0"/>
+          </a:p>
+        </p:txBody>
+      </p:sp>
+      <p:sp>
+        <p:nvSpPr>
+          <p:cNvPr id="7" name="Shape 5"/>
+          <p:cNvSpPr/>
+          <p:nvPr/>
+        </p:nvSpPr>
+        <p:spPr>
+          <a:xfrm>
+            <a:off x="548640" y="3154680"/>
+            <a:ext cx="3108960" cy="1188720"/>
+          </a:xfrm>
+          <a:prstGeom prst="roundRect">
+            <a:avLst>
+              <a:gd name="adj" fmla="val 9231"/>
+            </a:avLst>
+          </a:prstGeom>
+          <a:solidFill>
+            <a:srgbClr val="FFFFFF"/>
+          </a:solidFill>
+          <a:ln w="9525">
+            <a:solidFill>
+              <a:srgbClr val="D5E6E2"/>
+            </a:solidFill>
+            <a:prstDash val="solid"/>
+          </a:ln>
+          <a:effectLst>
+            <a:outerShdw sx="100000" sy="100000" kx="0" ky="0" algn="bl" rotWithShape="0" blurRad="127000" dist="25400" dir="5400000">
+              <a:srgbClr val="0B2B28">
+                <a:alpha val="12000"/>
+              </a:srgbClr>
+            </a:outerShdw>
+          </a:effectLst>
+        </p:spPr>
+      </p:sp>
+      <p:sp>
+        <p:nvSpPr>
+          <p:cNvPr id="8" name="Text 6"/>
+          <p:cNvSpPr txBox="1"/>
+          <p:nvPr/>
+        </p:nvSpPr>
+        <p:spPr>
+          <a:xfrm>
+            <a:off x="777240" y="3246120"/>
+            <a:ext cx="1005840" cy="1005840"/>
+          </a:xfrm>
+          <a:prstGeom prst="rect">
+            <a:avLst/>
+          </a:prstGeom>
+          <a:noFill/>
+          <a:ln/>
+        </p:spPr>
+        <p:txBody>
+          <a:bodyPr wrap="square" lIns="0" tIns="0" rIns="0" bIns="0" rtlCol="0" anchor="ctr"/>
+          <a:lstStyle/>
+          <a:p>
+            <a:pPr indent="0" marL="0">
+              <a:buNone/>
+            </a:pPr>
+            <a:r>
+              <a:rPr lang="en-US" sz="4000" b="1" dirty="0">
+                <a:solidFill>
+                  <a:srgbClr val="0F766E"/>
+                </a:solidFill>
+                <a:latin typeface="Arial" pitchFamily="34" charset="0"/>
+                <a:ea typeface="Arial" pitchFamily="34" charset="-122"/>
+                <a:cs typeface="Arial" pitchFamily="34" charset="-120"/>
+              </a:rPr>
+              <a:t>5</a:t>
+            </a:r>
+            <a:endParaRPr lang="en-US" sz="4000" dirty="0"/>
+          </a:p>
+        </p:txBody>
+      </p:sp>
+      <p:sp>
+        <p:nvSpPr>
+          <p:cNvPr id="9" name="Text 7"/>
+          <p:cNvSpPr txBox="1"/>
+          <p:nvPr/>
+        </p:nvSpPr>
+        <p:spPr>
+          <a:xfrm>
+            <a:off x="1783080" y="3246120"/>
+            <a:ext cx="1737360" cy="1005840"/>
+          </a:xfrm>
+          <a:prstGeom prst="rect">
+            <a:avLst/>
+          </a:prstGeom>
+          <a:noFill/>
+          <a:ln/>
+        </p:spPr>
+        <p:txBody>
+          <a:bodyPr wrap="square" lIns="0" tIns="0" rIns="0" bIns="0" rtlCol="0" anchor="ctr"/>
+          <a:lstStyle/>
+          <a:p>
+            <a:pPr indent="0" marL="0">
+              <a:buNone/>
+            </a:pPr>
+            <a:r>
+              <a:rPr lang="en-US" sz="1300" dirty="0">
+                <a:solidFill>
+                  <a:srgbClr val="5B6B6B"/>
+                </a:solidFill>
+                <a:latin typeface="Calibri" pitchFamily="34" charset="0"/>
+                <a:ea typeface="Calibri" pitchFamily="34" charset="-122"/>
+                <a:cs typeface="Calibri" pitchFamily="34" charset="-120"/>
+              </a:rPr>
+              <a:t>new tools to build DDRs faster</a:t>
+            </a:r>
+            <a:endParaRPr lang="en-US" sz="1300" dirty="0"/>
+          </a:p>
+        </p:txBody>
+      </p:sp>
+      <p:sp>
+        <p:nvSpPr>
+          <p:cNvPr id="10" name="Shape 8"/>
+          <p:cNvSpPr/>
+          <p:nvPr/>
+        </p:nvSpPr>
+        <p:spPr>
+          <a:xfrm>
+            <a:off x="548640" y="4526280"/>
+            <a:ext cx="3108960" cy="1188720"/>
+          </a:xfrm>
+          <a:prstGeom prst="roundRect">
+            <a:avLst>
+              <a:gd name="adj" fmla="val 9231"/>
+            </a:avLst>
+          </a:prstGeom>
+          <a:solidFill>
+            <a:srgbClr val="FFFFFF"/>
+          </a:solidFill>
+          <a:ln w="9525">
+            <a:solidFill>
+              <a:srgbClr val="D5E6E2"/>
+            </a:solidFill>
+            <a:prstDash val="solid"/>
+          </a:ln>
+          <a:effectLst>
+            <a:outerShdw sx="100000" sy="100000" kx="0" ky="0" algn="bl" rotWithShape="0" blurRad="127000" dist="25400" dir="5400000">
+              <a:srgbClr val="0B2B28">
+                <a:alpha val="12000"/>
+              </a:srgbClr>
+            </a:outerShdw>
+          </a:effectLst>
+        </p:spPr>
+      </p:sp>
+      <p:sp>
+        <p:nvSpPr>
+          <p:cNvPr id="11" name="Text 9"/>
+          <p:cNvSpPr txBox="1"/>
+          <p:nvPr/>
+        </p:nvSpPr>
+        <p:spPr>
+          <a:xfrm>
+            <a:off x="777240" y="4617720"/>
+            <a:ext cx="1005840" cy="1005840"/>
+          </a:xfrm>
+          <a:prstGeom prst="rect">
+            <a:avLst/>
+          </a:prstGeom>
+          <a:noFill/>
+          <a:ln/>
+        </p:spPr>
+        <p:txBody>
+          <a:bodyPr wrap="square" lIns="0" tIns="0" rIns="0" bIns="0" rtlCol="0" anchor="ctr"/>
+          <a:lstStyle/>
+          <a:p>
+            <a:pPr indent="0" marL="0">
+              <a:buNone/>
+            </a:pPr>
+            <a:r>
+              <a:rPr lang="en-US" sz="4000" b="1" dirty="0">
+                <a:solidFill>
+                  <a:srgbClr val="0F766E"/>
+                </a:solidFill>
+                <a:latin typeface="Arial" pitchFamily="34" charset="0"/>
+                <a:ea typeface="Arial" pitchFamily="34" charset="-122"/>
+                <a:cs typeface="Arial" pitchFamily="34" charset="-120"/>
+              </a:rPr>
+              <a:t>1</a:t>
+            </a:r>
+            <a:endParaRPr lang="en-US" sz="4000" dirty="0"/>
+          </a:p>
+        </p:txBody>
+      </p:sp>
+      <p:sp>
+        <p:nvSpPr>
+          <p:cNvPr id="12" name="Text 10"/>
+          <p:cNvSpPr txBox="1"/>
+          <p:nvPr/>
+        </p:nvSpPr>
+        <p:spPr>
+          <a:xfrm>
+            <a:off x="1783080" y="4617720"/>
+            <a:ext cx="1737360" cy="1005840"/>
+          </a:xfrm>
+          <a:prstGeom prst="rect">
+            <a:avLst/>
+          </a:prstGeom>
+          <a:noFill/>
+          <a:ln/>
+        </p:spPr>
+        <p:txBody>
+          <a:bodyPr wrap="square" lIns="0" tIns="0" rIns="0" bIns="0" rtlCol="0" anchor="ctr"/>
+          <a:lstStyle/>
+          <a:p>
+            <a:pPr indent="0" marL="0">
+              <a:buNone/>
+            </a:pPr>
+            <a:r>
+              <a:rPr lang="en-US" sz="1300" dirty="0">
+                <a:solidFill>
+                  <a:srgbClr val="5B6B6B"/>
+                </a:solidFill>
+                <a:latin typeface="Calibri" pitchFamily="34" charset="0"/>
+                <a:ea typeface="Calibri" pitchFamily="34" charset="-122"/>
+                <a:cs typeface="Calibri" pitchFamily="34" charset="-120"/>
+              </a:rPr>
+              <a:t>code path that loads the grid</a:t>
+            </a:r>
+            <a:endParaRPr lang="en-US" sz="1300" dirty="0"/>
+          </a:p>
+        </p:txBody>
+      </p:sp>
+      <p:sp>
+        <p:nvSpPr>
+          <p:cNvPr id="13" name="Shape 11"/>
+          <p:cNvSpPr/>
+          <p:nvPr/>
+        </p:nvSpPr>
+        <p:spPr>
+          <a:xfrm>
+            <a:off x="4023360" y="1783080"/>
+            <a:ext cx="7589520" cy="3931920"/>
+          </a:xfrm>
+          <a:prstGeom prst="roundRect">
+            <a:avLst>
+              <a:gd name="adj" fmla="val 2791"/>
+            </a:avLst>
+          </a:prstGeom>
+          <a:solidFill>
+            <a:srgbClr val="FFFFFF"/>
+          </a:solidFill>
+          <a:ln w="9525">
+            <a:solidFill>
+              <a:srgbClr val="D5E6E2"/>
+            </a:solidFill>
+            <a:prstDash val="solid"/>
+          </a:ln>
+          <a:effectLst>
+            <a:outerShdw sx="100000" sy="100000" kx="0" ky="0" algn="bl" rotWithShape="0" blurRad="127000" dist="25400" dir="5400000">
+              <a:srgbClr val="0B2B28">
+                <a:alpha val="12000"/>
+              </a:srgbClr>
+            </a:outerShdw>
+          </a:effectLst>
+        </p:spPr>
+      </p:sp>
+      <p:sp>
+        <p:nvSpPr>
+          <p:cNvPr id="14" name="Text 12"/>
+          <p:cNvSpPr txBox="1"/>
+          <p:nvPr/>
+        </p:nvSpPr>
+        <p:spPr>
+          <a:xfrm>
+            <a:off x="4343400" y="2011680"/>
+            <a:ext cx="6949440" cy="365760"/>
+          </a:xfrm>
+          <a:prstGeom prst="rect">
+            <a:avLst/>
+          </a:prstGeom>
+          <a:noFill/>
+          <a:ln/>
+        </p:spPr>
+        <p:txBody>
+          <a:bodyPr wrap="square" lIns="0" tIns="0" rIns="0" bIns="0" rtlCol="0" anchor="t"/>
+          <a:lstStyle/>
+          <a:p>
+            <a:pPr indent="0" marL="0">
+              <a:buNone/>
+            </a:pPr>
+            <a:r>
+              <a:rPr lang="en-US" sz="1700" b="1" dirty="0">
+                <a:solidFill>
+                  <a:srgbClr val="132828"/>
+                </a:solidFill>
+                <a:latin typeface="Arial" pitchFamily="34" charset="0"/>
+                <a:ea typeface="Arial" pitchFamily="34" charset="-122"/>
+                <a:cs typeface="Arial" pitchFamily="34" charset="-120"/>
+              </a:rPr>
+              <a:t>Highlights</a:t>
+            </a:r>
+            <a:endParaRPr lang="en-US" sz="1700" dirty="0"/>
+          </a:p>
+        </p:txBody>
+      </p:sp>
+      <p:sp>
+        <p:nvSpPr>
+          <p:cNvPr id="15" name="Text 13"/>
+          <p:cNvSpPr txBox="1"/>
+          <p:nvPr/>
+        </p:nvSpPr>
+        <p:spPr>
+          <a:xfrm>
+            <a:off x="4343400" y="2514600"/>
+            <a:ext cx="7040880" cy="3063240"/>
+          </a:xfrm>
+          <a:prstGeom prst="rect">
+            <a:avLst/>
+          </a:prstGeom>
+          <a:noFill/>
+          <a:ln/>
+        </p:spPr>
+        <p:txBody>
+          <a:bodyPr wrap="square" lIns="0" tIns="0" rIns="0" bIns="0" rtlCol="0" anchor="t"/>
+          <a:lstStyle/>
+          <a:p>
+            <a:pPr marL="342900" indent="-342900">
+              <a:spcAft>
+                <a:spcPts val="1100"/>
+              </a:spcAft>
+              <a:buSzPct val="100000"/>
+              <a:buChar char="•"/>
+            </a:pPr>
+            <a:r>
+              <a:rPr lang="en-US" sz="1600" dirty="0">
+                <a:solidFill>
+                  <a:srgbClr val="1F2A2A"/>
+                </a:solidFill>
+                <a:latin typeface="Calibri" pitchFamily="34" charset="0"/>
+                <a:ea typeface="Calibri" pitchFamily="34" charset="-122"/>
+                <a:cs typeface="Calibri" pitchFamily="34" charset="-120"/>
+              </a:rPr>
+              <a:t>Add DDR Line then Save All no longer duplicates saved rows</a:t>
+            </a:r>
+            <a:endParaRPr lang="en-US" sz="1600" dirty="0"/>
+          </a:p>
+          <a:p>
+            <a:pPr marL="342900" indent="-342900">
+              <a:spcAft>
+                <a:spcPts val="1100"/>
+              </a:spcAft>
+              <a:buSzPct val="100000"/>
+              <a:buChar char="•"/>
+            </a:pPr>
+            <a:r>
+              <a:rPr lang="en-US" sz="1600" dirty="0">
+                <a:solidFill>
+                  <a:srgbClr val="1F2A2A"/>
+                </a:solidFill>
+                <a:latin typeface="Calibri" pitchFamily="34" charset="0"/>
+                <a:ea typeface="Calibri" pitchFamily="34" charset="-122"/>
+                <a:cs typeface="Calibri" pitchFamily="34" charset="-120"/>
+              </a:rPr>
+              <a:t>Editing an existing line now updates it (Save All only inserted before)</a:t>
+            </a:r>
+            <a:endParaRPr lang="en-US" sz="1600" dirty="0"/>
+          </a:p>
+          <a:p>
+            <a:pPr marL="342900" indent="-342900">
+              <a:spcAft>
+                <a:spcPts val="1100"/>
+              </a:spcAft>
+              <a:buSzPct val="100000"/>
+              <a:buChar char="•"/>
+            </a:pPr>
+            <a:r>
+              <a:rPr lang="en-US" sz="1600" dirty="0">
+                <a:solidFill>
+                  <a:srgbClr val="1F2A2A"/>
+                </a:solidFill>
+                <a:latin typeface="Calibri" pitchFamily="34" charset="0"/>
+                <a:ea typeface="Calibri" pitchFamily="34" charset="-122"/>
+                <a:cs typeface="Calibri" pitchFamily="34" charset="-120"/>
+              </a:rPr>
+              <a:t>Delete works, for saved and unsaved rows</a:t>
+            </a:r>
+            <a:endParaRPr lang="en-US" sz="1600" dirty="0"/>
+          </a:p>
+          <a:p>
+            <a:pPr marL="342900" indent="-342900">
+              <a:spcAft>
+                <a:spcPts val="1100"/>
+              </a:spcAft>
+              <a:buSzPct val="100000"/>
+              <a:buChar char="•"/>
+            </a:pPr>
+            <a:r>
+              <a:rPr lang="en-US" sz="1600" dirty="0">
+                <a:solidFill>
+                  <a:srgbClr val="1F2A2A"/>
+                </a:solidFill>
+                <a:latin typeface="Calibri" pitchFamily="34" charset="0"/>
+                <a:ea typeface="Calibri" pitchFamily="34" charset="-122"/>
+                <a:cs typeface="Calibri" pitchFamily="34" charset="-120"/>
+              </a:rPr>
+              <a:t>Activity rows stay activity rows; Prev goes to the previous CTD</a:t>
+            </a:r>
+            <a:endParaRPr lang="en-US" sz="1600" dirty="0"/>
+          </a:p>
+          <a:p>
+            <a:pPr marL="342900" indent="-342900">
+              <a:spcAft>
+                <a:spcPts val="1100"/>
+              </a:spcAft>
+              <a:buSzPct val="100000"/>
+              <a:buChar char="•"/>
+            </a:pPr>
+            <a:r>
+              <a:rPr lang="en-US" sz="1600" dirty="0">
+                <a:solidFill>
+                  <a:srgbClr val="1F2A2A"/>
+                </a:solidFill>
+                <a:latin typeface="Calibri" pitchFamily="34" charset="0"/>
+                <a:ea typeface="Calibri" pitchFamily="34" charset="-122"/>
+                <a:cs typeface="Calibri" pitchFamily="34" charset="-120"/>
+              </a:rPr>
+              <a:t>Buttons no longer fire twice from double event wiring</a:t>
+            </a:r>
+            <a:endParaRPr lang="en-US" sz="1600" dirty="0"/>
+          </a:p>
+          <a:p>
+            <a:pPr marL="342900" indent="-342900">
+              <a:spcAft>
+                <a:spcPts val="1100"/>
+              </a:spcAft>
+              <a:buSzPct val="100000"/>
+              <a:buChar char="•"/>
+            </a:pPr>
+            <a:r>
+              <a:rPr lang="en-US" sz="1600" dirty="0">
+                <a:solidFill>
+                  <a:srgbClr val="1F2A2A"/>
+                </a:solidFill>
+                <a:latin typeface="Calibri" pitchFamily="34" charset="0"/>
+                <a:ea typeface="Calibri" pitchFamily="34" charset="-122"/>
+                <a:cs typeface="Calibri" pitchFamily="34" charset="-120"/>
+              </a:rPr>
+              <a:t>All lookups parameterised; error messages safely encoded</a:t>
+            </a:r>
+            <a:endParaRPr lang="en-US" sz="1600" dirty="0"/>
+          </a:p>
+        </p:txBody>
+      </p:sp>
+      <p:sp>
+        <p:nvSpPr>
+          <p:cNvPr id="16" name="Shape 14"/>
+          <p:cNvSpPr/>
+          <p:nvPr/>
+        </p:nvSpPr>
+        <p:spPr>
+          <a:xfrm>
+            <a:off x="548640" y="5852160"/>
+            <a:ext cx="11064240" cy="457200"/>
+          </a:xfrm>
+          <a:prstGeom prst="roundRect">
+            <a:avLst>
+              <a:gd name="adj" fmla="val 16000"/>
+            </a:avLst>
+          </a:prstGeom>
+          <a:solidFill>
+            <a:srgbClr val="E6F7F4"/>
+          </a:solidFill>
+          <a:ln w="12700">
+            <a:solidFill>
+              <a:srgbClr val="E6F7F4"/>
+            </a:solidFill>
+            <a:prstDash val="solid"/>
+          </a:ln>
+        </p:spPr>
+      </p:sp>
+      <p:sp>
+        <p:nvSpPr>
+          <p:cNvPr id="17" name="Text 15"/>
+          <p:cNvSpPr txBox="1"/>
+          <p:nvPr/>
+        </p:nvSpPr>
+        <p:spPr>
+          <a:xfrm>
+            <a:off x="777240" y="5852160"/>
+            <a:ext cx="10698480" cy="457200"/>
+          </a:xfrm>
+          <a:prstGeom prst="rect">
+            <a:avLst/>
+          </a:prstGeom>
+          <a:noFill/>
+          <a:ln/>
+        </p:spPr>
+        <p:txBody>
+          <a:bodyPr wrap="square" lIns="0" tIns="0" rIns="0" bIns="0" rtlCol="0" anchor="ctr"/>
+          <a:lstStyle/>
+          <a:p>
+            <a:pPr indent="0" marL="0">
+              <a:buNone/>
+            </a:pPr>
+            <a:r>
+              <a:rPr lang="en-US" sz="1300" b="1" dirty="0">
+                <a:solidFill>
+                  <a:srgbClr val="0F766E"/>
+                </a:solidFill>
+                <a:latin typeface="Calibri" pitchFamily="34" charset="0"/>
+                <a:ea typeface="Calibri" pitchFamily="34" charset="-122"/>
+                <a:cs typeface="Calibri" pitchFamily="34" charset="-120"/>
+              </a:rPr>
+              <a:t>Follow-up: </a:t>
+            </a:r>
+            <a:pPr indent="0" marL="0">
+              <a:buNone/>
+            </a:pPr>
+            <a:r>
+              <a:rPr lang="en-US" sz="1300" dirty="0">
+                <a:solidFill>
+                  <a:srgbClr val="0F766E"/>
+                </a:solidFill>
+                <a:latin typeface="Calibri" pitchFamily="34" charset="0"/>
+                <a:ea typeface="Calibri" pitchFamily="34" charset="-122"/>
+                <a:cs typeface="Calibri" pitchFamily="34" charset="-120"/>
+              </a:rPr>
+              <a:t>Previous / Next CTD is still fixed to project 40087 and 13. Process, as in the original; it should follow the open project.</a:t>
+            </a:r>
+            <a:endParaRPr lang="en-US" sz="1300" dirty="0"/>
+          </a:p>
+        </p:txBody>
+      </p:sp>
+      <p:sp>
+        <p:nvSpPr>
+          <p:cNvPr id="18" name="Text 16"/>
+          <p:cNvSpPr txBox="1"/>
+          <p:nvPr/>
+        </p:nvSpPr>
+        <p:spPr>
+          <a:xfrm>
+            <a:off x="548640" y="6446520"/>
+            <a:ext cx="5486400" cy="274320"/>
+          </a:xfrm>
+          <a:prstGeom prst="rect">
+            <a:avLst/>
+          </a:prstGeom>
+          <a:noFill/>
+          <a:ln/>
+        </p:spPr>
+        <p:txBody>
+          <a:bodyPr wrap="square" lIns="0" tIns="0" rIns="0" bIns="0" rtlCol="0" anchor="ctr"/>
+          <a:lstStyle/>
+          <a:p>
+            <a:pPr indent="0" marL="0">
+              <a:buNone/>
+            </a:pPr>
+            <a:r>
+              <a:rPr lang="en-US" sz="1000" dirty="0">
+                <a:solidFill>
+                  <a:srgbClr val="8A9A98"/>
+                </a:solidFill>
+                <a:latin typeface="Calibri" pitchFamily="34" charset="0"/>
+                <a:ea typeface="Calibri" pitchFamily="34" charset="-122"/>
+                <a:cs typeface="Calibri" pitchFamily="34" charset="-120"/>
+              </a:rPr>
+              <a:t>SmartDDR v3 · DDR Dashboard · DDR Developer</a:t>
+            </a:r>
+            <a:endParaRPr lang="en-US" sz="1000" dirty="0"/>
+          </a:p>
+        </p:txBody>
+      </p:sp>
+      <p:sp>
+        <p:nvSpPr>
+          <p:cNvPr id="19" name="Text 17"/>
+          <p:cNvSpPr txBox="1"/>
+          <p:nvPr/>
+        </p:nvSpPr>
+        <p:spPr>
+          <a:xfrm>
+            <a:off x="11064240" y="6446520"/>
+            <a:ext cx="576072" cy="274320"/>
+          </a:xfrm>
+          <a:prstGeom prst="rect">
+            <a:avLst/>
+          </a:prstGeom>
+          <a:noFill/>
+          <a:ln/>
+        </p:spPr>
+        <p:txBody>
+          <a:bodyPr wrap="square" lIns="0" tIns="0" rIns="0" bIns="0" rtlCol="0" anchor="ctr"/>
+          <a:lstStyle/>
+          <a:p>
+            <a:pPr algn="r" indent="0" marL="0">
+              <a:buNone/>
+            </a:pPr>
+            <a:r>
+              <a:rPr lang="en-US" sz="1000" dirty="0">
+                <a:solidFill>
+                  <a:srgbClr val="8A9A98"/>
+                </a:solidFill>
+                <a:latin typeface="Calibri" pitchFamily="34" charset="0"/>
+                <a:ea typeface="Calibri" pitchFamily="34" charset="-122"/>
+                <a:cs typeface="Calibri" pitchFamily="34" charset="-120"/>
+              </a:rPr>
+              <a:t>20</a:t>
+            </a:r>
+            <a:endParaRPr lang="en-US" sz="1000" dirty="0"/>
+          </a:p>
+        </p:txBody>
+      </p:sp>
+    </p:spTree>
+  </p:cSld>
+  <p:clrMapOvr>
+    <a:masterClrMapping/>
+  </p:clrMapOvr>
+</p:sld>
+</file>
+
+<file path=ppt/slides/slide21.xml><?xml version="1.0" encoding="utf-8"?>
+<p:sld xmlns:a="http://schemas.openxmlformats.org/drawingml/2006/main" xmlns:r="http://schemas.openxmlformats.org/officeDocument/2006/relationships" xmlns:p="http://schemas.openxmlformats.org/presentationml/2006/main">
+  <p:cSld name="Slide 21">
+    <p:bg>
+      <p:bgPr>
+        <a:blipFill dpi="0" rotWithShape="1">
+          <a:blip r:embed="rId1">
+            <a:lum/>
+          </a:blip>
+          <a:srcRect/>
+          <a:stretch>
+            <a:fillRect/>
+          </a:stretch>
+        </a:blipFill>
+        <a:effectLst/>
+      </p:bgPr>
+    </p:bg>
+    <p:spTree>
+      <p:nvGrpSpPr>
+        <p:cNvPr id="1" name=""/>
+        <p:cNvGrpSpPr/>
+        <p:nvPr/>
+      </p:nvGrpSpPr>
+      <p:grpSpPr>
+        <a:xfrm>
+          <a:off x="0" y="0"/>
+          <a:ext cx="0" cy="0"/>
+          <a:chOff x="0" y="0"/>
+          <a:chExt cx="0" cy="0"/>
+        </a:xfrm>
+      </p:grpSpPr>
+      <p:sp>
+        <p:nvSpPr>
+          <p:cNvPr id="2" name="Text 0"/>
+          <p:cNvSpPr txBox="1"/>
+          <p:nvPr/>
+        </p:nvSpPr>
+        <p:spPr>
+          <a:xfrm>
+            <a:off x="548640" y="822960"/>
+            <a:ext cx="6400800" cy="822960"/>
+          </a:xfrm>
+          <a:prstGeom prst="rect">
+            <a:avLst/>
+          </a:prstGeom>
+          <a:noFill/>
+          <a:ln/>
+        </p:spPr>
+        <p:txBody>
+          <a:bodyPr wrap="square" lIns="0" tIns="0" rIns="0" bIns="0" rtlCol="0" anchor="ctr"/>
+          <a:lstStyle/>
+          <a:p>
+            <a:pPr indent="0" marL="0">
+              <a:buNone/>
+            </a:pPr>
+            <a:r>
+              <a:rPr lang="en-US" sz="4000" b="1" dirty="0">
+                <a:solidFill>
+                  <a:srgbClr val="FFFFFF"/>
+                </a:solidFill>
+                <a:latin typeface="Arial" pitchFamily="34" charset="0"/>
+                <a:ea typeface="Arial" pitchFamily="34" charset="-122"/>
+                <a:cs typeface="Arial" pitchFamily="34" charset="-120"/>
+              </a:rPr>
+              <a:t>Next steps</a:t>
+            </a:r>
+            <a:endParaRPr lang="en-US" sz="4000" dirty="0"/>
+          </a:p>
+        </p:txBody>
+      </p:sp>
+      <p:sp>
+        <p:nvSpPr>
+          <p:cNvPr id="3" name="Shape 1"/>
+          <p:cNvSpPr/>
+          <p:nvPr/>
+        </p:nvSpPr>
+        <p:spPr>
+          <a:xfrm>
+            <a:off x="548640" y="1828800"/>
+            <a:ext cx="548640" cy="548640"/>
+          </a:xfrm>
+          <a:prstGeom prst="ellipse">
+            <a:avLst/>
+          </a:prstGeom>
+          <a:solidFill>
+            <a:srgbClr val="14B8A6"/>
+          </a:solidFill>
+          <a:ln w="12700">
+            <a:solidFill>
+              <a:srgbClr val="14B8A6"/>
+            </a:solidFill>
+            <a:prstDash val="solid"/>
+          </a:ln>
+        </p:spPr>
+      </p:sp>
+      <p:pic>
+        <p:nvPicPr>
+          <p:cNvPr id="4" name="Image 0" descr="preencoded.png">    </p:cNvPr>
+          <p:cNvPicPr>
+            <a:picLocks noChangeAspect="1"/>
+          </p:cNvPicPr>
+          <p:nvPr/>
+        </p:nvPicPr>
+        <p:blipFill>
+          <a:blip r:embed="rId2"/>
+          <a:stretch>
+            <a:fillRect/>
+          </a:stretch>
+        </p:blipFill>
+        <p:spPr>
+          <a:xfrm>
+            <a:off x="691286" y="1971446"/>
+            <a:ext cx="263347" cy="263347"/>
+          </a:xfrm>
+          <a:prstGeom prst="rect">
+            <a:avLst/>
+          </a:prstGeom>
+        </p:spPr>
+      </p:pic>
+      <p:sp>
+        <p:nvSpPr>
+          <p:cNvPr id="5" name="Text 2"/>
+          <p:cNvSpPr txBox="1"/>
+          <p:nvPr/>
+        </p:nvSpPr>
+        <p:spPr>
+          <a:xfrm>
+            <a:off x="1280160" y="1828800"/>
+            <a:ext cx="5120640" cy="548640"/>
+          </a:xfrm>
+          <a:prstGeom prst="rect">
+            <a:avLst/>
+          </a:prstGeom>
+          <a:noFill/>
+          <a:ln/>
+        </p:spPr>
+        <p:txBody>
+          <a:bodyPr wrap="square" lIns="0" tIns="0" rIns="0" bIns="0" rtlCol="0" anchor="ctr"/>
+          <a:lstStyle/>
+          <a:p>
+            <a:pPr indent="0" marL="0">
+              <a:buNone/>
+            </a:pPr>
+            <a:r>
+              <a:rPr lang="en-US" sz="1900" dirty="0">
+                <a:solidFill>
+                  <a:srgbClr val="FFFFFF"/>
+                </a:solidFill>
+                <a:latin typeface="Calibri" pitchFamily="34" charset="0"/>
+                <a:ea typeface="Calibri" pitchFamily="34" charset="-122"/>
+                <a:cs typeface="Calibri" pitchFamily="34" charset="-120"/>
+              </a:rPr>
+              <a:t>Agree the pilot project and users</a:t>
+            </a:r>
+            <a:endParaRPr lang="en-US" sz="1900" dirty="0"/>
+          </a:p>
+        </p:txBody>
+      </p:sp>
+      <p:sp>
+        <p:nvSpPr>
+          <p:cNvPr id="6" name="Shape 3"/>
+          <p:cNvSpPr/>
+          <p:nvPr/>
+        </p:nvSpPr>
+        <p:spPr>
+          <a:xfrm>
+            <a:off x="548640" y="2596896"/>
+            <a:ext cx="548640" cy="548640"/>
+          </a:xfrm>
+          <a:prstGeom prst="ellipse">
+            <a:avLst/>
+          </a:prstGeom>
+          <a:solidFill>
+            <a:srgbClr val="14B8A6"/>
+          </a:solidFill>
+          <a:ln w="12700">
+            <a:solidFill>
+              <a:srgbClr val="14B8A6"/>
+            </a:solidFill>
+            <a:prstDash val="solid"/>
+          </a:ln>
+        </p:spPr>
+      </p:sp>
+      <p:pic>
+        <p:nvPicPr>
+          <p:cNvPr id="7" name="Image 1" descr="preencoded.png">    </p:cNvPr>
+          <p:cNvPicPr>
+            <a:picLocks noChangeAspect="1"/>
+          </p:cNvPicPr>
+          <p:nvPr/>
+        </p:nvPicPr>
+        <p:blipFill>
+          <a:blip r:embed="rId3"/>
+          <a:stretch>
+            <a:fillRect/>
+          </a:stretch>
+        </p:blipFill>
+        <p:spPr>
+          <a:xfrm>
+            <a:off x="691286" y="2739542"/>
+            <a:ext cx="263347" cy="263347"/>
+          </a:xfrm>
+          <a:prstGeom prst="rect">
+            <a:avLst/>
+          </a:prstGeom>
+        </p:spPr>
+      </p:pic>
+      <p:sp>
+        <p:nvSpPr>
+          <p:cNvPr id="8" name="Text 4"/>
+          <p:cNvSpPr txBox="1"/>
+          <p:nvPr/>
+        </p:nvSpPr>
+        <p:spPr>
+          <a:xfrm>
+            <a:off x="1280160" y="2596896"/>
+            <a:ext cx="5120640" cy="548640"/>
+          </a:xfrm>
+          <a:prstGeom prst="rect">
+            <a:avLst/>
+          </a:prstGeom>
+          <a:noFill/>
+          <a:ln/>
+        </p:spPr>
+        <p:txBody>
+          <a:bodyPr wrap="square" lIns="0" tIns="0" rIns="0" bIns="0" rtlCol="0" anchor="ctr"/>
+          <a:lstStyle/>
+          <a:p>
+            <a:pPr indent="0" marL="0">
+              <a:buNone/>
+            </a:pPr>
+            <a:r>
+              <a:rPr lang="en-US" sz="1900" dirty="0">
+                <a:solidFill>
+                  <a:srgbClr val="FFFFFF"/>
+                </a:solidFill>
+                <a:latin typeface="Calibri" pitchFamily="34" charset="0"/>
+                <a:ea typeface="Calibri" pitchFamily="34" charset="-122"/>
+                <a:cs typeface="Calibri" pitchFamily="34" charset="-120"/>
+              </a:rPr>
+              <a:t>Run the setup script and enable the nightly job</a:t>
+            </a:r>
+            <a:endParaRPr lang="en-US" sz="1900" dirty="0"/>
+          </a:p>
+        </p:txBody>
+      </p:sp>
+      <p:sp>
+        <p:nvSpPr>
+          <p:cNvPr id="9" name="Shape 5"/>
+          <p:cNvSpPr/>
+          <p:nvPr/>
+        </p:nvSpPr>
+        <p:spPr>
+          <a:xfrm>
+            <a:off x="548640" y="3364992"/>
+            <a:ext cx="548640" cy="548640"/>
+          </a:xfrm>
+          <a:prstGeom prst="ellipse">
+            <a:avLst/>
+          </a:prstGeom>
+          <a:solidFill>
+            <a:srgbClr val="14B8A6"/>
+          </a:solidFill>
+          <a:ln w="12700">
+            <a:solidFill>
+              <a:srgbClr val="14B8A6"/>
+            </a:solidFill>
+            <a:prstDash val="solid"/>
+          </a:ln>
+        </p:spPr>
+      </p:sp>
+      <p:pic>
+        <p:nvPicPr>
+          <p:cNvPr id="10" name="Image 2" descr="preencoded.png">    </p:cNvPr>
+          <p:cNvPicPr>
+            <a:picLocks noChangeAspect="1"/>
+          </p:cNvPicPr>
+          <p:nvPr/>
+        </p:nvPicPr>
+        <p:blipFill>
+          <a:blip r:embed="rId4"/>
+          <a:stretch>
+            <a:fillRect/>
+          </a:stretch>
+        </p:blipFill>
+        <p:spPr>
+          <a:xfrm>
+            <a:off x="691286" y="3507638"/>
+            <a:ext cx="263347" cy="263347"/>
+          </a:xfrm>
+          <a:prstGeom prst="rect">
+            <a:avLst/>
+          </a:prstGeom>
+        </p:spPr>
+      </p:pic>
+      <p:sp>
+        <p:nvSpPr>
+          <p:cNvPr id="11" name="Text 6"/>
+          <p:cNvSpPr txBox="1"/>
+          <p:nvPr/>
+        </p:nvSpPr>
+        <p:spPr>
+          <a:xfrm>
+            <a:off x="1280160" y="3364992"/>
+            <a:ext cx="5120640" cy="548640"/>
+          </a:xfrm>
+          <a:prstGeom prst="rect">
+            <a:avLst/>
+          </a:prstGeom>
+          <a:noFill/>
+          <a:ln/>
+        </p:spPr>
+        <p:txBody>
+          <a:bodyPr wrap="square" lIns="0" tIns="0" rIns="0" bIns="0" rtlCol="0" anchor="ctr"/>
+          <a:lstStyle/>
+          <a:p>
+            <a:pPr indent="0" marL="0">
+              <a:buNone/>
+            </a:pPr>
+            <a:r>
+              <a:rPr lang="en-US" sz="1900" dirty="0">
+                <a:solidFill>
+                  <a:srgbClr val="FFFFFF"/>
+                </a:solidFill>
+                <a:latin typeface="Calibri" pitchFamily="34" charset="0"/>
+                <a:ea typeface="Calibri" pitchFamily="34" charset="-122"/>
+                <a:cs typeface="Calibri" pitchFamily="34" charset="-120"/>
+              </a:rPr>
+              <a:t>Capture the first baseline</a:t>
+            </a:r>
+            <a:endParaRPr lang="en-US" sz="1900" dirty="0"/>
+          </a:p>
+        </p:txBody>
+      </p:sp>
+      <p:sp>
+        <p:nvSpPr>
+          <p:cNvPr id="12" name="Shape 7"/>
+          <p:cNvSpPr/>
+          <p:nvPr/>
+        </p:nvSpPr>
+        <p:spPr>
+          <a:xfrm>
+            <a:off x="548640" y="4133088"/>
+            <a:ext cx="548640" cy="548640"/>
+          </a:xfrm>
+          <a:prstGeom prst="ellipse">
+            <a:avLst/>
+          </a:prstGeom>
+          <a:solidFill>
+            <a:srgbClr val="14B8A6"/>
+          </a:solidFill>
+          <a:ln w="12700">
+            <a:solidFill>
+              <a:srgbClr val="14B8A6"/>
+            </a:solidFill>
+            <a:prstDash val="solid"/>
+          </a:ln>
+        </p:spPr>
+      </p:sp>
+      <p:pic>
+        <p:nvPicPr>
+          <p:cNvPr id="13" name="Image 3" descr="preencoded.png">    </p:cNvPr>
+          <p:cNvPicPr>
+            <a:picLocks noChangeAspect="1"/>
+          </p:cNvPicPr>
+          <p:nvPr/>
+        </p:nvPicPr>
+        <p:blipFill>
+          <a:blip r:embed="rId5"/>
+          <a:stretch>
+            <a:fillRect/>
+          </a:stretch>
+        </p:blipFill>
+        <p:spPr>
+          <a:xfrm>
+            <a:off x="691286" y="4275734"/>
+            <a:ext cx="263347" cy="263347"/>
+          </a:xfrm>
+          <a:prstGeom prst="rect">
+            <a:avLst/>
+          </a:prstGeom>
+        </p:spPr>
+      </p:pic>
+      <p:sp>
+        <p:nvSpPr>
+          <p:cNvPr id="14" name="Text 8"/>
+          <p:cNvSpPr txBox="1"/>
+          <p:nvPr/>
+        </p:nvSpPr>
+        <p:spPr>
+          <a:xfrm>
+            <a:off x="1280160" y="4133088"/>
+            <a:ext cx="5120640" cy="548640"/>
+          </a:xfrm>
+          <a:prstGeom prst="rect">
+            <a:avLst/>
+          </a:prstGeom>
+          <a:noFill/>
+          <a:ln/>
+        </p:spPr>
+        <p:txBody>
+          <a:bodyPr wrap="square" lIns="0" tIns="0" rIns="0" bIns="0" rtlCol="0" anchor="ctr"/>
+          <a:lstStyle/>
+          <a:p>
+            <a:pPr indent="0" marL="0">
+              <a:buNone/>
+            </a:pPr>
+            <a:r>
+              <a:rPr lang="en-US" sz="1900" dirty="0">
+                <a:solidFill>
+                  <a:srgbClr val="FFFFFF"/>
+                </a:solidFill>
+                <a:latin typeface="Calibri" pitchFamily="34" charset="0"/>
+                <a:ea typeface="Calibri" pitchFamily="34" charset="-122"/>
+                <a:cs typeface="Calibri" pitchFamily="34" charset="-120"/>
+              </a:rPr>
+              <a:t>Review after two weeks of trend data</a:t>
+            </a:r>
+            <a:endParaRPr lang="en-US" sz="1900" dirty="0"/>
+          </a:p>
+        </p:txBody>
+      </p:sp>
+      <p:sp>
+        <p:nvSpPr>
+          <p:cNvPr id="15" name="Shape 9"/>
+          <p:cNvSpPr/>
+          <p:nvPr/>
+        </p:nvSpPr>
+        <p:spPr>
+          <a:xfrm>
+            <a:off x="548640" y="4901184"/>
+            <a:ext cx="548640" cy="548640"/>
+          </a:xfrm>
+          <a:prstGeom prst="ellipse">
+            <a:avLst/>
+          </a:prstGeom>
+          <a:solidFill>
+            <a:srgbClr val="14B8A6"/>
+          </a:solidFill>
+          <a:ln w="12700">
+            <a:solidFill>
+              <a:srgbClr val="14B8A6"/>
+            </a:solidFill>
+            <a:prstDash val="solid"/>
+          </a:ln>
+        </p:spPr>
+      </p:sp>
+      <p:pic>
+        <p:nvPicPr>
+          <p:cNvPr id="16" name="Image 4" descr="preencoded.png">    </p:cNvPr>
+          <p:cNvPicPr>
+            <a:picLocks noChangeAspect="1"/>
+          </p:cNvPicPr>
+          <p:nvPr/>
+        </p:nvPicPr>
+        <p:blipFill>
+          <a:blip r:embed="rId6"/>
+          <a:stretch>
+            <a:fillRect/>
+          </a:stretch>
+        </p:blipFill>
+        <p:spPr>
+          <a:xfrm>
+            <a:off x="691286" y="5043830"/>
+            <a:ext cx="263347" cy="263347"/>
+          </a:xfrm>
+          <a:prstGeom prst="rect">
+            <a:avLst/>
+          </a:prstGeom>
+        </p:spPr>
+      </p:pic>
+      <p:sp>
+        <p:nvSpPr>
+          <p:cNvPr id="17" name="Text 10"/>
+          <p:cNvSpPr txBox="1"/>
+          <p:nvPr/>
+        </p:nvSpPr>
+        <p:spPr>
+          <a:xfrm>
+            <a:off x="1280160" y="4901184"/>
+            <a:ext cx="5120640" cy="548640"/>
+          </a:xfrm>
+          <a:prstGeom prst="rect">
+            <a:avLst/>
+          </a:prstGeom>
+          <a:noFill/>
+          <a:ln/>
+        </p:spPr>
+        <p:txBody>
+          <a:bodyPr wrap="square" lIns="0" tIns="0" rIns="0" bIns="0" rtlCol="0" anchor="ctr"/>
+          <a:lstStyle/>
+          <a:p>
+            <a:pPr indent="0" marL="0">
+              <a:buNone/>
+            </a:pPr>
+            <a:r>
+              <a:rPr lang="en-US" sz="1900" dirty="0">
+                <a:solidFill>
+                  <a:srgbClr val="FFFFFF"/>
+                </a:solidFill>
+                <a:latin typeface="Calibri" pitchFamily="34" charset="0"/>
+                <a:ea typeface="Calibri" pitchFamily="34" charset="-122"/>
+                <a:cs typeface="Calibri" pitchFamily="34" charset="-120"/>
+              </a:rPr>
+              <a:t>Scope DDR Developer Prev / Next to the open project</a:t>
+            </a:r>
+            <a:endParaRPr lang="en-US" sz="1900" dirty="0"/>
+          </a:p>
+        </p:txBody>
+      </p:sp>
+      <p:sp>
+        <p:nvSpPr>
+          <p:cNvPr id="18" name="Text 11"/>
+          <p:cNvSpPr txBox="1"/>
+          <p:nvPr/>
+        </p:nvSpPr>
+        <p:spPr>
+          <a:xfrm>
+            <a:off x="548640" y="5852160"/>
+            <a:ext cx="4572000" cy="548640"/>
+          </a:xfrm>
+          <a:prstGeom prst="rect">
+            <a:avLst/>
+          </a:prstGeom>
+          <a:noFill/>
+          <a:ln/>
+        </p:spPr>
+        <p:txBody>
+          <a:bodyPr wrap="square" lIns="0" tIns="0" rIns="0" bIns="0" rtlCol="0" anchor="ctr"/>
+          <a:lstStyle/>
+          <a:p>
+            <a:pPr indent="0" marL="0">
+              <a:buNone/>
+            </a:pPr>
+            <a:r>
+              <a:rPr lang="en-US" sz="2200" b="1" dirty="0">
+                <a:solidFill>
+                  <a:srgbClr val="14B8A6"/>
+                </a:solidFill>
+                <a:latin typeface="Arial" pitchFamily="34" charset="0"/>
+                <a:ea typeface="Arial" pitchFamily="34" charset="-122"/>
+                <a:cs typeface="Arial" pitchFamily="34" charset="-120"/>
+              </a:rPr>
+              <a:t>Thank you</a:t>
+            </a:r>
+            <a:endParaRPr lang="en-US" sz="2200" dirty="0"/>
+          </a:p>
+        </p:txBody>
+      </p:sp>
+      <p:sp>
+        <p:nvSpPr>
+          <p:cNvPr id="19" name="Shape 12"/>
+          <p:cNvSpPr/>
+          <p:nvPr/>
+        </p:nvSpPr>
+        <p:spPr>
+          <a:xfrm>
+            <a:off x="6693408" y="1389888"/>
+            <a:ext cx="4992624" cy="3175254"/>
+          </a:xfrm>
+          <a:prstGeom prst="roundRect">
+            <a:avLst>
+              <a:gd name="adj" fmla="val 2880"/>
+            </a:avLst>
+          </a:prstGeom>
+          <a:solidFill>
+            <a:srgbClr val="0E3533"/>
+          </a:solidFill>
+          <a:ln w="9525">
+            <a:solidFill>
+              <a:srgbClr val="2A6B64"/>
+            </a:solidFill>
+            <a:prstDash val="solid"/>
+          </a:ln>
+          <a:effectLst>
+            <a:outerShdw sx="100000" sy="100000" kx="0" ky="0" algn="bl" rotWithShape="0" blurRad="177800" dist="50800" dir="5400000">
+              <a:srgbClr val="0B2B28">
+                <a:alpha val="22000"/>
+              </a:srgbClr>
+            </a:outerShdw>
+          </a:effectLst>
+        </p:spPr>
+      </p:sp>
+      <p:pic>
+        <p:nvPicPr>
+          <p:cNvPr id="20" name="Image 5" descr="/tmp/claude-0/-home-user-BlazerTest/4e1a4774-871d-567d-86ff-c2c6a1597caf/scratchpad/deck/img/trend.jpg">    </p:cNvPr>
+          <p:cNvPicPr>
+            <a:picLocks noChangeAspect="1"/>
+          </p:cNvPicPr>
+          <p:nvPr/>
+        </p:nvPicPr>
+        <p:blipFill>
+          <a:blip r:embed="rId7"/>
+          <a:stretch>
+            <a:fillRect/>
+          </a:stretch>
+        </p:blipFill>
+        <p:spPr>
+          <a:xfrm>
+            <a:off x="6766560" y="1463040"/>
+            <a:ext cx="4846320" cy="3028950"/>
+          </a:xfrm>
+          <a:prstGeom prst="rect">
+            <a:avLst/>
+          </a:prstGeom>
+        </p:spPr>
+      </p:pic>
     </p:spTree>
   </p:cSld>
   <p:clrMapOvr>
@@ -10219,7 +13563,7 @@
                 <a:ea typeface="Calibri" pitchFamily="34" charset="-122"/>
                 <a:cs typeface="Calibri" pitchFamily="34" charset="-120"/>
               </a:rPr>
-              <a:t>SmartDDR v3 · DDR Dashboard</a:t>
+              <a:t>SmartDDR v3 · DDR Dashboard · DDR Developer</a:t>
             </a:r>
             <a:endParaRPr lang="en-US" sz="1000" dirty="0"/>
           </a:p>
@@ -11177,7 +14521,7 @@
                 <a:ea typeface="Calibri" pitchFamily="34" charset="-122"/>
                 <a:cs typeface="Calibri" pitchFamily="34" charset="-120"/>
               </a:rPr>
-              <a:t>SmartDDR v3 · DDR Dashboard</a:t>
+              <a:t>SmartDDR v3 · DDR Dashboard · DDR Developer</a:t>
             </a:r>
             <a:endParaRPr lang="en-US" sz="1000" dirty="0"/>
           </a:p>
@@ -12338,7 +15682,7 @@
                 <a:ea typeface="Calibri" pitchFamily="34" charset="-122"/>
                 <a:cs typeface="Calibri" pitchFamily="34" charset="-120"/>
               </a:rPr>
-              <a:t>SmartDDR v3 · DDR Dashboard</a:t>
+              <a:t>SmartDDR v3 · DDR Dashboard · DDR Developer</a:t>
             </a:r>
             <a:endParaRPr lang="en-US" sz="1000" dirty="0"/>
           </a:p>
@@ -12630,7 +15974,7 @@
                 <a:ea typeface="Calibri" pitchFamily="34" charset="-122"/>
                 <a:cs typeface="Calibri" pitchFamily="34" charset="-120"/>
               </a:rPr>
-              <a:t>SmartDDR v3 · DDR Dashboard</a:t>
+              <a:t>SmartDDR v3 · DDR Dashboard · DDR Developer</a:t>
             </a:r>
             <a:endParaRPr lang="en-US" sz="1000" dirty="0"/>
           </a:p>
@@ -13518,7 +16862,7 @@
                 <a:ea typeface="Calibri" pitchFamily="34" charset="-122"/>
                 <a:cs typeface="Calibri" pitchFamily="34" charset="-120"/>
               </a:rPr>
-              <a:t>SmartDDR v3 · DDR Dashboard</a:t>
+              <a:t>SmartDDR v3 · DDR Dashboard · DDR Developer</a:t>
             </a:r>
             <a:endParaRPr lang="en-US" sz="1000" dirty="0"/>
           </a:p>
@@ -15241,7 +18585,7 @@
                 <a:ea typeface="Calibri" pitchFamily="34" charset="-122"/>
                 <a:cs typeface="Calibri" pitchFamily="34" charset="-120"/>
               </a:rPr>
-              <a:t>SmartDDR v3 · DDR Dashboard</a:t>
+              <a:t>SmartDDR v3 · DDR Dashboard · DDR Developer</a:t>
             </a:r>
             <a:endParaRPr lang="en-US" sz="1000" dirty="0"/>
           </a:p>
@@ -15910,7 +19254,7 @@
                 <a:ea typeface="Calibri" pitchFamily="34" charset="-122"/>
                 <a:cs typeface="Calibri" pitchFamily="34" charset="-120"/>
               </a:rPr>
-              <a:t>SmartDDR v3 · DDR Dashboard</a:t>
+              <a:t>SmartDDR v3 · DDR Dashboard · DDR Developer</a:t>
             </a:r>
             <a:endParaRPr lang="en-US" sz="1000" dirty="0"/>
           </a:p>

</xml_diff>

<commit_message>
Add DDR Developer user guide; refresh DDR Developer slides
- guides/DDR-Developer: user guide page with screenshots (sample data)
- presentation: DDR Developer screenshots now match DDR_DeveloperV3 behaviour

Co-Authored-By: Claude Opus 5.5 <noreply@anthropic.com>
Claude-Session: https://claude.ai/code/session_017FnutsU6w5KK1m4HU6hRuq
</commit_message>
<xml_diff>
--- a/SmartDDRv3/presentation/SmartDDR-Presentation.pptx
+++ b/SmartDDRv3/presentation/SmartDDR-Presentation.pptx
@@ -8680,11 +8680,11 @@
         <p:spPr>
           <a:xfrm>
             <a:off x="6327648" y="1664208"/>
-            <a:ext cx="5358384" cy="3078099"/>
+            <a:ext cx="5358384" cy="2859843"/>
           </a:xfrm>
           <a:prstGeom prst="roundRect">
             <a:avLst>
-              <a:gd name="adj" fmla="val 2971"/>
+              <a:gd name="adj" fmla="val 3197"/>
             </a:avLst>
           </a:prstGeom>
           <a:solidFill>
@@ -8722,7 +8722,7 @@
         <p:spPr>
           <a:xfrm>
             <a:off x="6400800" y="1737360"/>
-            <a:ext cx="5212080" cy="2931795"/>
+            <a:ext cx="5212080" cy="2713539"/>
           </a:xfrm>
           <a:prstGeom prst="rect">
             <a:avLst/>
@@ -8933,11 +8933,11 @@
         <p:spPr>
           <a:xfrm>
             <a:off x="475488" y="1709928"/>
-            <a:ext cx="6821424" cy="3901059"/>
+            <a:ext cx="6821424" cy="3621538"/>
           </a:xfrm>
           <a:prstGeom prst="roundRect">
             <a:avLst>
-              <a:gd name="adj" fmla="val 2344"/>
+              <a:gd name="adj" fmla="val 2525"/>
             </a:avLst>
           </a:prstGeom>
           <a:solidFill>
@@ -8975,7 +8975,7 @@
         <p:spPr>
           <a:xfrm>
             <a:off x="548640" y="1783080"/>
-            <a:ext cx="6675120" cy="3754755"/>
+            <a:ext cx="6675120" cy="3475234"/>
           </a:xfrm>
           <a:prstGeom prst="rect">
             <a:avLst/>
@@ -9820,12 +9820,12 @@
         </p:nvSpPr>
         <p:spPr>
           <a:xfrm>
-            <a:off x="5138928" y="1709928"/>
-            <a:ext cx="6547104" cy="3746754"/>
+            <a:off x="5138928" y="2029968"/>
+            <a:ext cx="6547104" cy="3163824"/>
           </a:xfrm>
           <a:prstGeom prst="roundRect">
             <a:avLst>
-              <a:gd name="adj" fmla="val 2441"/>
+              <a:gd name="adj" fmla="val 2890"/>
             </a:avLst>
           </a:prstGeom>
           <a:solidFill>
@@ -9862,8 +9862,8 @@
         </p:blipFill>
         <p:spPr>
           <a:xfrm>
-            <a:off x="5212080" y="1783080"/>
-            <a:ext cx="6400800" cy="3600450"/>
+            <a:off x="5212080" y="2103120"/>
+            <a:ext cx="6400800" cy="3017520"/>
           </a:xfrm>
           <a:prstGeom prst="rect">
             <a:avLst/>

</xml_diff>